<commit_message>
MAS-UI,Server PPT, PDF 변경
</commit_message>
<xml_diff>
--- a/document/MAS-Server.pptx
+++ b/document/MAS-Server.pptx
@@ -10,15 +10,15 @@
   <p:sldIdLst>
     <p:sldId id="257" r:id="rId2"/>
     <p:sldId id="259" r:id="rId3"/>
-    <p:sldId id="292" r:id="rId4"/>
-    <p:sldId id="260" r:id="rId5"/>
-    <p:sldId id="261" r:id="rId6"/>
-    <p:sldId id="290" r:id="rId7"/>
-    <p:sldId id="293" r:id="rId8"/>
-    <p:sldId id="294" r:id="rId9"/>
-    <p:sldId id="295" r:id="rId10"/>
-    <p:sldId id="296" r:id="rId11"/>
-    <p:sldId id="273" r:id="rId12"/>
+    <p:sldId id="261" r:id="rId4"/>
+    <p:sldId id="298" r:id="rId5"/>
+    <p:sldId id="290" r:id="rId6"/>
+    <p:sldId id="293" r:id="rId7"/>
+    <p:sldId id="294" r:id="rId8"/>
+    <p:sldId id="295" r:id="rId9"/>
+    <p:sldId id="296" r:id="rId10"/>
+    <p:sldId id="273" r:id="rId11"/>
+    <p:sldId id="297" r:id="rId12"/>
   </p:sldIdLst>
   <p:sldSz cx="12192000" cy="6858000"/>
   <p:notesSz cx="6858000" cy="9144000"/>
@@ -207,7 +207,7 @@
           <a:p>
             <a:fld id="{39BCABF5-0E2C-44E8-B1E9-C479705C3948}" type="datetimeFigureOut">
               <a:rPr lang="ko-KR" altLang="en-US" smtClean="0"/>
-              <a:t>2025-09-01</a:t>
+              <a:t>2026-02-11</a:t>
             </a:fld>
             <a:endParaRPr lang="ko-KR" altLang="en-US"/>
           </a:p>
@@ -622,7 +622,7 @@
           <a:p>
             <a:fld id="{49DFE29B-93A1-40D1-A604-D00555902BE4}" type="datetimeFigureOut">
               <a:rPr lang="ko-KR" altLang="en-US" smtClean="0"/>
-              <a:t>2025-09-01</a:t>
+              <a:t>2026-02-11</a:t>
             </a:fld>
             <a:endParaRPr lang="ko-KR" altLang="en-US"/>
           </a:p>
@@ -820,7 +820,7 @@
           <a:p>
             <a:fld id="{49DFE29B-93A1-40D1-A604-D00555902BE4}" type="datetimeFigureOut">
               <a:rPr lang="ko-KR" altLang="en-US" smtClean="0"/>
-              <a:t>2025-09-01</a:t>
+              <a:t>2026-02-11</a:t>
             </a:fld>
             <a:endParaRPr lang="ko-KR" altLang="en-US"/>
           </a:p>
@@ -1028,7 +1028,7 @@
           <a:p>
             <a:fld id="{49DFE29B-93A1-40D1-A604-D00555902BE4}" type="datetimeFigureOut">
               <a:rPr lang="ko-KR" altLang="en-US" smtClean="0"/>
-              <a:t>2025-09-01</a:t>
+              <a:t>2026-02-11</a:t>
             </a:fld>
             <a:endParaRPr lang="ko-KR" altLang="en-US"/>
           </a:p>
@@ -1226,7 +1226,7 @@
           <a:p>
             <a:fld id="{49DFE29B-93A1-40D1-A604-D00555902BE4}" type="datetimeFigureOut">
               <a:rPr lang="ko-KR" altLang="en-US" smtClean="0"/>
-              <a:t>2025-09-01</a:t>
+              <a:t>2026-02-11</a:t>
             </a:fld>
             <a:endParaRPr lang="ko-KR" altLang="en-US"/>
           </a:p>
@@ -1501,7 +1501,7 @@
           <a:p>
             <a:fld id="{49DFE29B-93A1-40D1-A604-D00555902BE4}" type="datetimeFigureOut">
               <a:rPr lang="ko-KR" altLang="en-US" smtClean="0"/>
-              <a:t>2025-09-01</a:t>
+              <a:t>2026-02-11</a:t>
             </a:fld>
             <a:endParaRPr lang="ko-KR" altLang="en-US"/>
           </a:p>
@@ -1766,7 +1766,7 @@
           <a:p>
             <a:fld id="{49DFE29B-93A1-40D1-A604-D00555902BE4}" type="datetimeFigureOut">
               <a:rPr lang="ko-KR" altLang="en-US" smtClean="0"/>
-              <a:t>2025-09-01</a:t>
+              <a:t>2026-02-11</a:t>
             </a:fld>
             <a:endParaRPr lang="ko-KR" altLang="en-US"/>
           </a:p>
@@ -2178,7 +2178,7 @@
           <a:p>
             <a:fld id="{49DFE29B-93A1-40D1-A604-D00555902BE4}" type="datetimeFigureOut">
               <a:rPr lang="ko-KR" altLang="en-US" smtClean="0"/>
-              <a:t>2025-09-01</a:t>
+              <a:t>2026-02-11</a:t>
             </a:fld>
             <a:endParaRPr lang="ko-KR" altLang="en-US"/>
           </a:p>
@@ -2319,7 +2319,7 @@
           <a:p>
             <a:fld id="{49DFE29B-93A1-40D1-A604-D00555902BE4}" type="datetimeFigureOut">
               <a:rPr lang="ko-KR" altLang="en-US" smtClean="0"/>
-              <a:t>2025-09-01</a:t>
+              <a:t>2026-02-11</a:t>
             </a:fld>
             <a:endParaRPr lang="ko-KR" altLang="en-US"/>
           </a:p>
@@ -2432,7 +2432,7 @@
           <a:p>
             <a:fld id="{49DFE29B-93A1-40D1-A604-D00555902BE4}" type="datetimeFigureOut">
               <a:rPr lang="ko-KR" altLang="en-US" smtClean="0"/>
-              <a:t>2025-09-01</a:t>
+              <a:t>2026-02-11</a:t>
             </a:fld>
             <a:endParaRPr lang="ko-KR" altLang="en-US"/>
           </a:p>
@@ -2743,7 +2743,7 @@
           <a:p>
             <a:fld id="{49DFE29B-93A1-40D1-A604-D00555902BE4}" type="datetimeFigureOut">
               <a:rPr lang="ko-KR" altLang="en-US" smtClean="0"/>
-              <a:t>2025-09-01</a:t>
+              <a:t>2026-02-11</a:t>
             </a:fld>
             <a:endParaRPr lang="ko-KR" altLang="en-US"/>
           </a:p>
@@ -3031,7 +3031,7 @@
           <a:p>
             <a:fld id="{49DFE29B-93A1-40D1-A604-D00555902BE4}" type="datetimeFigureOut">
               <a:rPr lang="ko-KR" altLang="en-US" smtClean="0"/>
-              <a:t>2025-09-01</a:t>
+              <a:t>2026-02-11</a:t>
             </a:fld>
             <a:endParaRPr lang="ko-KR" altLang="en-US"/>
           </a:p>
@@ -3272,7 +3272,7 @@
           <a:p>
             <a:fld id="{49DFE29B-93A1-40D1-A604-D00555902BE4}" type="datetimeFigureOut">
               <a:rPr lang="ko-KR" altLang="en-US" smtClean="0"/>
-              <a:t>2025-09-01</a:t>
+              <a:t>2026-02-11</a:t>
             </a:fld>
             <a:endParaRPr lang="ko-KR" altLang="en-US"/>
           </a:p>
@@ -3706,11 +3706,7 @@
           <a:p>
             <a:r>
               <a:rPr lang="en-US" altLang="ko-KR" dirty="0" smtClean="0"/>
-              <a:t>MAS-</a:t>
-            </a:r>
-            <a:r>
-              <a:rPr lang="en-US" altLang="ko-KR" dirty="0" smtClean="0"/>
-              <a:t>Server</a:t>
+              <a:t>MAS-Server</a:t>
             </a:r>
             <a:endParaRPr lang="ko-KR" altLang="en-US" dirty="0"/>
           </a:p>
@@ -3837,13 +3833,1141 @@
         </p:nvSpPr>
         <p:spPr>
           <a:xfrm>
+            <a:off x="0" y="0"/>
+            <a:ext cx="12192000" cy="1457011"/>
+          </a:xfrm>
+        </p:spPr>
+        <p:txBody>
+          <a:bodyPr/>
+          <a:lstStyle/>
+          <a:p>
+            <a:r>
+              <a:rPr lang="en-US" altLang="ko-KR" b="1" dirty="0" smtClean="0"/>
+              <a:t> Result </a:t>
+            </a:r>
+            <a:r>
+              <a:rPr lang="en-US" altLang="ko-KR" b="1" dirty="0"/>
+              <a:t>Notes</a:t>
+            </a:r>
+            <a:endParaRPr lang="ko-KR" altLang="en-US" dirty="0"/>
+          </a:p>
+        </p:txBody>
+      </p:sp>
+      <p:sp>
+        <p:nvSpPr>
+          <p:cNvPr id="3" name="내용 개체 틀 2"/>
+          <p:cNvSpPr>
+            <a:spLocks noGrp="1"/>
+          </p:cNvSpPr>
+          <p:nvPr>
+            <p:ph idx="1"/>
+          </p:nvPr>
+        </p:nvSpPr>
+        <p:spPr>
+          <a:xfrm>
+            <a:off x="0" y="1245996"/>
+            <a:ext cx="11353800" cy="4941015"/>
+          </a:xfrm>
+        </p:spPr>
+        <p:txBody>
+          <a:bodyPr/>
+          <a:lstStyle/>
+          <a:p>
+            <a:r>
+              <a:rPr lang="ko-KR" altLang="en-US" dirty="0" smtClean="0"/>
+              <a:t>통합 </a:t>
+            </a:r>
+            <a:r>
+              <a:rPr lang="en-US" altLang="ko-KR" dirty="0" smtClean="0"/>
+              <a:t>UI </a:t>
+            </a:r>
+            <a:r>
+              <a:rPr lang="ko-KR" altLang="en-US" dirty="0" smtClean="0"/>
+              <a:t>하나로 </a:t>
+            </a:r>
+            <a:r>
+              <a:rPr lang="en-US" altLang="ko-KR" dirty="0" smtClean="0"/>
+              <a:t>EDA Operation </a:t>
+            </a:r>
+            <a:r>
+              <a:rPr lang="ko-KR" altLang="en-US" dirty="0" smtClean="0"/>
+              <a:t>수행 가능</a:t>
+            </a:r>
+            <a:r>
+              <a:rPr lang="en-US" altLang="ko-KR" dirty="0" smtClean="0"/>
+              <a:t>.</a:t>
+            </a:r>
+          </a:p>
+          <a:p>
+            <a:r>
+              <a:rPr lang="ko-KR" altLang="en-US" dirty="0" smtClean="0"/>
+              <a:t>안정적인 </a:t>
+            </a:r>
+            <a:r>
+              <a:rPr lang="en-US" altLang="ko-KR" dirty="0" err="1" smtClean="0"/>
+              <a:t>Redis</a:t>
+            </a:r>
+            <a:r>
+              <a:rPr lang="en-US" altLang="ko-KR" dirty="0" smtClean="0"/>
+              <a:t> </a:t>
+            </a:r>
+            <a:r>
+              <a:rPr lang="ko-KR" altLang="en-US" dirty="0" smtClean="0"/>
+              <a:t>통신 가능</a:t>
+            </a:r>
+            <a:endParaRPr lang="en-US" altLang="ko-KR" dirty="0" smtClean="0"/>
+          </a:p>
+          <a:p>
+            <a:r>
+              <a:rPr lang="en-US" altLang="ko-KR" dirty="0" err="1" smtClean="0"/>
+              <a:t>DBType</a:t>
+            </a:r>
+            <a:r>
+              <a:rPr lang="en-US" altLang="ko-KR" dirty="0" smtClean="0"/>
+              <a:t> </a:t>
+            </a:r>
+            <a:r>
+              <a:rPr lang="ko-KR" altLang="en-US" dirty="0" smtClean="0"/>
+              <a:t>에 따른 </a:t>
+            </a:r>
+            <a:r>
+              <a:rPr lang="en-US" altLang="ko-KR" dirty="0" err="1" smtClean="0"/>
+              <a:t>Swich</a:t>
+            </a:r>
+            <a:r>
+              <a:rPr lang="en-US" altLang="ko-KR" dirty="0" smtClean="0"/>
+              <a:t> </a:t>
+            </a:r>
+            <a:r>
+              <a:rPr lang="ko-KR" altLang="en-US" dirty="0" smtClean="0"/>
+              <a:t>용이</a:t>
+            </a:r>
+            <a:r>
+              <a:rPr lang="en-US" altLang="ko-KR" dirty="0" smtClean="0"/>
+              <a:t>.</a:t>
+            </a:r>
+          </a:p>
+          <a:p>
+            <a:r>
+              <a:rPr lang="en-US" altLang="ko-KR" dirty="0" smtClean="0"/>
+              <a:t>Data </a:t>
+            </a:r>
+            <a:r>
+              <a:rPr lang="ko-KR" altLang="en-US" dirty="0" smtClean="0"/>
+              <a:t>끊김 없이 </a:t>
+            </a:r>
+            <a:r>
+              <a:rPr lang="en-US" altLang="ko-KR" dirty="0" smtClean="0"/>
+              <a:t>Proxy </a:t>
+            </a:r>
+            <a:r>
+              <a:rPr lang="ko-KR" altLang="en-US" dirty="0" smtClean="0"/>
+              <a:t>관리 가능</a:t>
+            </a:r>
+            <a:r>
+              <a:rPr lang="en-US" altLang="ko-KR" dirty="0" smtClean="0"/>
+              <a:t>.</a:t>
+            </a:r>
+          </a:p>
+          <a:p>
+            <a:r>
+              <a:rPr lang="ko-KR" altLang="en-US" dirty="0" smtClean="0"/>
+              <a:t>전체적인 </a:t>
+            </a:r>
+            <a:r>
+              <a:rPr lang="ko-KR" altLang="en-US" dirty="0" err="1" smtClean="0"/>
+              <a:t>리팩토링</a:t>
+            </a:r>
+            <a:r>
+              <a:rPr lang="ko-KR" altLang="en-US" dirty="0" smtClean="0"/>
+              <a:t> 수행으로 메모리 약 </a:t>
+            </a:r>
+            <a:r>
+              <a:rPr lang="en-US" altLang="ko-KR" dirty="0" smtClean="0"/>
+              <a:t>30% </a:t>
+            </a:r>
+            <a:r>
+              <a:rPr lang="ko-KR" altLang="en-US" dirty="0" smtClean="0"/>
+              <a:t>감소</a:t>
+            </a:r>
+            <a:r>
+              <a:rPr lang="en-US" altLang="ko-KR" dirty="0" smtClean="0"/>
+              <a:t>.</a:t>
+            </a:r>
+          </a:p>
+          <a:p>
+            <a:pPr marL="0" indent="0">
+              <a:buNone/>
+            </a:pPr>
+            <a:r>
+              <a:rPr lang="en-US" altLang="ko-KR" dirty="0" smtClean="0"/>
+              <a:t> -&gt; </a:t>
+            </a:r>
+            <a:r>
+              <a:rPr lang="ko-KR" altLang="en-US" dirty="0" smtClean="0"/>
+              <a:t>재사용 되지 않고있던 </a:t>
+            </a:r>
+            <a:r>
+              <a:rPr lang="en-US" altLang="ko-KR" dirty="0" smtClean="0"/>
+              <a:t>Client, </a:t>
+            </a:r>
+            <a:r>
+              <a:rPr lang="ko-KR" altLang="en-US" dirty="0" smtClean="0"/>
+              <a:t>많은 양의 데이터를 한 줄씩 </a:t>
+            </a:r>
+            <a:r>
+              <a:rPr lang="en-US" altLang="ko-KR" dirty="0" smtClean="0"/>
+              <a:t>Insert </a:t>
+            </a:r>
+            <a:r>
+              <a:rPr lang="ko-KR" altLang="en-US" dirty="0" smtClean="0"/>
+              <a:t>하던 쿼리 등 수정</a:t>
+            </a:r>
+            <a:r>
+              <a:rPr lang="en-US" altLang="ko-KR" dirty="0" smtClean="0"/>
+              <a:t>.</a:t>
+            </a:r>
+            <a:endParaRPr lang="en-US" altLang="ko-KR" dirty="0" smtClean="0"/>
+          </a:p>
+          <a:p>
+            <a:pPr marL="0" indent="0">
+              <a:buNone/>
+            </a:pPr>
+            <a:endParaRPr lang="en-US" altLang="ko-KR" dirty="0"/>
+          </a:p>
+          <a:p>
+            <a:pPr marL="0" indent="0">
+              <a:buNone/>
+            </a:pPr>
+            <a:endParaRPr lang="en-US" altLang="ko-KR" dirty="0" smtClean="0"/>
+          </a:p>
+          <a:p>
+            <a:endParaRPr lang="ko-KR" altLang="en-US" dirty="0"/>
+          </a:p>
+        </p:txBody>
+      </p:sp>
+    </p:spTree>
+    <p:extLst>
+      <p:ext uri="{BB962C8B-B14F-4D97-AF65-F5344CB8AC3E}">
+        <p14:creationId xmlns:p14="http://schemas.microsoft.com/office/powerpoint/2010/main" val="2034695615"/>
+      </p:ext>
+    </p:extLst>
+  </p:cSld>
+  <p:clrMapOvr>
+    <a:masterClrMapping/>
+  </p:clrMapOvr>
+  <p:timing>
+    <p:tnLst>
+      <p:par>
+        <p:cTn id="1" dur="indefinite" restart="never" nodeType="tmRoot"/>
+      </p:par>
+    </p:tnLst>
+  </p:timing>
+</p:sld>
+</file>
+
+<file path=ppt/slides/slide11.xml><?xml version="1.0" encoding="utf-8"?>
+<p:sld xmlns:a="http://schemas.openxmlformats.org/drawingml/2006/main" xmlns:r="http://schemas.openxmlformats.org/officeDocument/2006/relationships" xmlns:p="http://schemas.openxmlformats.org/presentationml/2006/main">
+  <p:cSld>
+    <p:spTree>
+      <p:nvGrpSpPr>
+        <p:cNvPr id="1" name=""/>
+        <p:cNvGrpSpPr/>
+        <p:nvPr/>
+      </p:nvGrpSpPr>
+      <p:grpSpPr>
+        <a:xfrm>
+          <a:off x="0" y="0"/>
+          <a:ext cx="0" cy="0"/>
+          <a:chOff x="0" y="0"/>
+          <a:chExt cx="0" cy="0"/>
+        </a:xfrm>
+      </p:grpSpPr>
+      <p:sp>
+        <p:nvSpPr>
+          <p:cNvPr id="2" name="제목 1"/>
+          <p:cNvSpPr>
+            <a:spLocks noGrp="1"/>
+          </p:cNvSpPr>
+          <p:nvPr>
+            <p:ph type="title"/>
+          </p:nvPr>
+        </p:nvSpPr>
+        <p:spPr>
+          <a:xfrm>
+            <a:off x="0" y="0"/>
+            <a:ext cx="12192000" cy="1457011"/>
+          </a:xfrm>
+        </p:spPr>
+        <p:txBody>
+          <a:bodyPr/>
+          <a:lstStyle/>
+          <a:p>
+            <a:r>
+              <a:rPr lang="en-US" altLang="ko-KR" b="1" dirty="0" smtClean="0"/>
+              <a:t> License </a:t>
+            </a:r>
+            <a:r>
+              <a:rPr lang="en-US" altLang="ko-KR" b="1" dirty="0"/>
+              <a:t>Notes</a:t>
+            </a:r>
+            <a:endParaRPr lang="ko-KR" altLang="en-US" dirty="0"/>
+          </a:p>
+        </p:txBody>
+      </p:sp>
+      <p:sp>
+        <p:nvSpPr>
+          <p:cNvPr id="3" name="내용 개체 틀 2"/>
+          <p:cNvSpPr>
+            <a:spLocks noGrp="1"/>
+          </p:cNvSpPr>
+          <p:nvPr>
+            <p:ph idx="1"/>
+          </p:nvPr>
+        </p:nvSpPr>
+        <p:spPr>
+          <a:xfrm>
+            <a:off x="0" y="1245996"/>
+            <a:ext cx="11353800" cy="4941015"/>
+          </a:xfrm>
+        </p:spPr>
+        <p:txBody>
+          <a:bodyPr/>
+          <a:lstStyle/>
+          <a:p>
+            <a:pPr marL="0" indent="0">
+              <a:buNone/>
+            </a:pPr>
+            <a:endParaRPr lang="en-US" altLang="ko-KR" dirty="0"/>
+          </a:p>
+          <a:p>
+            <a:r>
+              <a:rPr lang="en-US" altLang="ko-KR" dirty="0" smtClean="0"/>
+              <a:t>License </a:t>
+            </a:r>
+            <a:r>
+              <a:rPr lang="ko-KR" altLang="en-US" dirty="0" smtClean="0"/>
+              <a:t>목록</a:t>
+            </a:r>
+            <a:endParaRPr lang="en-US" altLang="ko-KR" dirty="0" smtClean="0"/>
+          </a:p>
+          <a:p>
+            <a:endParaRPr lang="ko-KR" altLang="en-US" dirty="0"/>
+          </a:p>
+        </p:txBody>
+      </p:sp>
+      <p:graphicFrame>
+        <p:nvGraphicFramePr>
+          <p:cNvPr id="6" name="개체 5"/>
+          <p:cNvGraphicFramePr>
+            <a:graphicFrameLocks noChangeAspect="1"/>
+          </p:cNvGraphicFramePr>
+          <p:nvPr>
+            <p:extLst>
+              <p:ext uri="{D42A27DB-BD31-4B8C-83A1-F6EECF244321}">
+                <p14:modId xmlns:p14="http://schemas.microsoft.com/office/powerpoint/2010/main" val="783335040"/>
+              </p:ext>
+            </p:extLst>
+          </p:nvPr>
+        </p:nvGraphicFramePr>
+        <p:xfrm>
+          <a:off x="2703041" y="1753944"/>
+          <a:ext cx="1096963" cy="533400"/>
+        </p:xfrm>
+        <a:graphic>
+          <a:graphicData uri="http://schemas.openxmlformats.org/presentationml/2006/ole">
+            <mc:AlternateContent xmlns:mc="http://schemas.openxmlformats.org/markup-compatibility/2006">
+              <mc:Choice xmlns:v="urn:schemas-microsoft-com:vml" Requires="v">
+                <p:oleObj spid="_x0000_s1032" name="포장기 셸 개체" showAsIcon="1" r:id="rId3" imgW="1096920" imgH="532800" progId="Package">
+                  <p:embed/>
+                </p:oleObj>
+              </mc:Choice>
+              <mc:Fallback>
+                <p:oleObj name="포장기 셸 개체" showAsIcon="1" r:id="rId3" imgW="1096920" imgH="532800" progId="Package">
+                  <p:embed/>
+                  <p:pic>
+                    <p:nvPicPr>
+                      <p:cNvPr id="0" name=""/>
+                      <p:cNvPicPr/>
+                      <p:nvPr/>
+                    </p:nvPicPr>
+                    <p:blipFill>
+                      <a:blip r:embed="rId4"/>
+                      <a:stretch>
+                        <a:fillRect/>
+                      </a:stretch>
+                    </p:blipFill>
+                    <p:spPr>
+                      <a:xfrm>
+                        <a:off x="2703041" y="1753944"/>
+                        <a:ext cx="1096963" cy="533400"/>
+                      </a:xfrm>
+                      <a:prstGeom prst="rect">
+                        <a:avLst/>
+                      </a:prstGeom>
+                    </p:spPr>
+                  </p:pic>
+                </p:oleObj>
+              </mc:Fallback>
+            </mc:AlternateContent>
+          </a:graphicData>
+        </a:graphic>
+      </p:graphicFrame>
+    </p:spTree>
+    <p:extLst>
+      <p:ext uri="{BB962C8B-B14F-4D97-AF65-F5344CB8AC3E}">
+        <p14:creationId xmlns:p14="http://schemas.microsoft.com/office/powerpoint/2010/main" val="3442155081"/>
+      </p:ext>
+    </p:extLst>
+  </p:cSld>
+  <p:clrMapOvr>
+    <a:masterClrMapping/>
+  </p:clrMapOvr>
+  <p:timing>
+    <p:tnLst>
+      <p:par>
+        <p:cTn id="1" dur="indefinite" restart="never" nodeType="tmRoot"/>
+      </p:par>
+    </p:tnLst>
+  </p:timing>
+</p:sld>
+</file>
+
+<file path=ppt/slides/slide2.xml><?xml version="1.0" encoding="utf-8"?>
+<p:sld xmlns:a="http://schemas.openxmlformats.org/drawingml/2006/main" xmlns:r="http://schemas.openxmlformats.org/officeDocument/2006/relationships" xmlns:p="http://schemas.openxmlformats.org/presentationml/2006/main">
+  <p:cSld>
+    <p:spTree>
+      <p:nvGrpSpPr>
+        <p:cNvPr id="1" name=""/>
+        <p:cNvGrpSpPr/>
+        <p:nvPr/>
+      </p:nvGrpSpPr>
+      <p:grpSpPr>
+        <a:xfrm>
+          <a:off x="0" y="0"/>
+          <a:ext cx="0" cy="0"/>
+          <a:chOff x="0" y="0"/>
+          <a:chExt cx="0" cy="0"/>
+        </a:xfrm>
+      </p:grpSpPr>
+      <p:sp>
+        <p:nvSpPr>
+          <p:cNvPr id="2" name="제목 1"/>
+          <p:cNvSpPr>
+            <a:spLocks noGrp="1"/>
+          </p:cNvSpPr>
+          <p:nvPr>
+            <p:ph type="title"/>
+          </p:nvPr>
+        </p:nvSpPr>
+        <p:spPr>
+          <a:xfrm>
+            <a:off x="0" y="0"/>
+            <a:ext cx="12192000" cy="1055078"/>
+          </a:xfrm>
+        </p:spPr>
+        <p:txBody>
+          <a:bodyPr/>
+          <a:lstStyle/>
+          <a:p>
+            <a:r>
+              <a:rPr lang="en-US" altLang="ko-KR" b="1" dirty="0" smtClean="0"/>
+              <a:t> Introduction</a:t>
+            </a:r>
+            <a:endParaRPr lang="ko-KR" altLang="en-US" dirty="0"/>
+          </a:p>
+        </p:txBody>
+      </p:sp>
+      <p:sp>
+        <p:nvSpPr>
+          <p:cNvPr id="3" name="내용 개체 틀 2"/>
+          <p:cNvSpPr>
+            <a:spLocks noGrp="1"/>
+          </p:cNvSpPr>
+          <p:nvPr>
+            <p:ph idx="1"/>
+          </p:nvPr>
+        </p:nvSpPr>
+        <p:spPr>
+          <a:xfrm>
+            <a:off x="0" y="1055078"/>
+            <a:ext cx="12192000" cy="5802922"/>
+          </a:xfrm>
+        </p:spPr>
+        <p:txBody>
+          <a:bodyPr/>
+          <a:lstStyle/>
+          <a:p>
+            <a:r>
+              <a:rPr lang="en-US" altLang="ko-KR" dirty="0" smtClean="0"/>
+              <a:t>EDA </a:t>
+            </a:r>
+            <a:r>
+              <a:rPr lang="ko-KR" altLang="en-US" dirty="0" smtClean="0"/>
+              <a:t>전반적인 통합 </a:t>
+            </a:r>
+            <a:r>
+              <a:rPr lang="en-US" altLang="ko-KR" dirty="0" smtClean="0"/>
+              <a:t>UI </a:t>
+            </a:r>
+            <a:r>
+              <a:rPr lang="ko-KR" altLang="en-US" dirty="0" smtClean="0"/>
+              <a:t>시스템 필요</a:t>
+            </a:r>
+            <a:r>
+              <a:rPr lang="en-US" altLang="ko-KR" dirty="0" smtClean="0"/>
+              <a:t>.</a:t>
+            </a:r>
+          </a:p>
+          <a:p>
+            <a:r>
+              <a:rPr lang="en-US" altLang="ko-KR" dirty="0" smtClean="0"/>
+              <a:t>Rest API </a:t>
+            </a:r>
+            <a:r>
+              <a:rPr lang="ko-KR" altLang="en-US" dirty="0" smtClean="0"/>
+              <a:t>통신</a:t>
+            </a:r>
+            <a:endParaRPr lang="en-US" altLang="ko-KR" dirty="0" smtClean="0"/>
+          </a:p>
+          <a:p>
+            <a:r>
+              <a:rPr lang="en-US" altLang="ko-KR" dirty="0" smtClean="0"/>
+              <a:t>UI(Client) </a:t>
+            </a:r>
+            <a:r>
+              <a:rPr lang="ko-KR" altLang="en-US" dirty="0" smtClean="0"/>
+              <a:t>와 </a:t>
+            </a:r>
+            <a:r>
+              <a:rPr lang="en-US" altLang="ko-KR" dirty="0" smtClean="0"/>
+              <a:t>EQ, Consumer, DB, </a:t>
+            </a:r>
+            <a:r>
+              <a:rPr lang="en-US" altLang="ko-KR" dirty="0" err="1" smtClean="0"/>
+              <a:t>Redis</a:t>
+            </a:r>
+            <a:r>
+              <a:rPr lang="en-US" altLang="ko-KR" dirty="0" smtClean="0"/>
+              <a:t> </a:t>
+            </a:r>
+            <a:r>
+              <a:rPr lang="ko-KR" altLang="en-US" dirty="0" smtClean="0"/>
+              <a:t>를 연결 하는 </a:t>
+            </a:r>
+            <a:r>
+              <a:rPr lang="en-US" altLang="ko-KR" dirty="0" smtClean="0"/>
+              <a:t>Server </a:t>
+            </a:r>
+            <a:r>
+              <a:rPr lang="ko-KR" altLang="en-US" dirty="0" smtClean="0"/>
+              <a:t>프로그램 필요</a:t>
+            </a:r>
+            <a:r>
+              <a:rPr lang="en-US" altLang="ko-KR" dirty="0" smtClean="0"/>
+              <a:t>.</a:t>
+            </a:r>
+          </a:p>
+          <a:p>
+            <a:r>
+              <a:rPr lang="en-US" altLang="ko-KR" dirty="0" smtClean="0"/>
+              <a:t>VIP </a:t>
+            </a:r>
+            <a:r>
+              <a:rPr lang="ko-KR" altLang="en-US" dirty="0" smtClean="0"/>
+              <a:t>를 통해 </a:t>
+            </a:r>
+            <a:r>
+              <a:rPr lang="en-US" altLang="ko-KR" dirty="0" smtClean="0"/>
+              <a:t>Fail Over </a:t>
+            </a:r>
+            <a:r>
+              <a:rPr lang="ko-KR" altLang="en-US" dirty="0" smtClean="0"/>
+              <a:t>기능 포함</a:t>
+            </a:r>
+            <a:r>
+              <a:rPr lang="en-US" altLang="ko-KR" dirty="0"/>
+              <a:t>.</a:t>
+            </a:r>
+            <a:endParaRPr lang="en-US" altLang="ko-KR" dirty="0" smtClean="0"/>
+          </a:p>
+        </p:txBody>
+      </p:sp>
+    </p:spTree>
+    <p:extLst>
+      <p:ext uri="{BB962C8B-B14F-4D97-AF65-F5344CB8AC3E}">
+        <p14:creationId xmlns:p14="http://schemas.microsoft.com/office/powerpoint/2010/main" val="3312636876"/>
+      </p:ext>
+    </p:extLst>
+  </p:cSld>
+  <p:clrMapOvr>
+    <a:masterClrMapping/>
+  </p:clrMapOvr>
+  <p:timing>
+    <p:tnLst>
+      <p:par>
+        <p:cTn id="1" dur="indefinite" restart="never" nodeType="tmRoot"/>
+      </p:par>
+    </p:tnLst>
+  </p:timing>
+</p:sld>
+</file>
+
+<file path=ppt/slides/slide3.xml><?xml version="1.0" encoding="utf-8"?>
+<p:sld xmlns:a="http://schemas.openxmlformats.org/drawingml/2006/main" xmlns:r="http://schemas.openxmlformats.org/officeDocument/2006/relationships" xmlns:p="http://schemas.openxmlformats.org/presentationml/2006/main">
+  <p:cSld>
+    <p:spTree>
+      <p:nvGrpSpPr>
+        <p:cNvPr id="1" name=""/>
+        <p:cNvGrpSpPr/>
+        <p:nvPr/>
+      </p:nvGrpSpPr>
+      <p:grpSpPr>
+        <a:xfrm>
+          <a:off x="0" y="0"/>
+          <a:ext cx="0" cy="0"/>
+          <a:chOff x="0" y="0"/>
+          <a:chExt cx="0" cy="0"/>
+        </a:xfrm>
+      </p:grpSpPr>
+      <p:sp>
+        <p:nvSpPr>
+          <p:cNvPr id="2" name="제목 1"/>
+          <p:cNvSpPr>
+            <a:spLocks noGrp="1"/>
+          </p:cNvSpPr>
+          <p:nvPr>
+            <p:ph type="title"/>
+          </p:nvPr>
+        </p:nvSpPr>
+        <p:spPr>
+          <a:xfrm>
+            <a:off x="0" y="-1"/>
+            <a:ext cx="12192000" cy="1032470"/>
+          </a:xfrm>
+        </p:spPr>
+        <p:txBody>
+          <a:bodyPr/>
+          <a:lstStyle/>
+          <a:p>
+            <a:r>
+              <a:rPr lang="en-US" altLang="ko-KR" b="1" dirty="0" smtClean="0"/>
+              <a:t> Scope</a:t>
+            </a:r>
+            <a:endParaRPr lang="ko-KR" altLang="en-US" dirty="0"/>
+          </a:p>
+        </p:txBody>
+      </p:sp>
+      <p:sp>
+        <p:nvSpPr>
+          <p:cNvPr id="3" name="내용 개체 틀 2"/>
+          <p:cNvSpPr>
+            <a:spLocks noGrp="1"/>
+          </p:cNvSpPr>
+          <p:nvPr>
+            <p:ph idx="1"/>
+          </p:nvPr>
+        </p:nvSpPr>
+        <p:spPr>
+          <a:xfrm>
+            <a:off x="0" y="1032470"/>
+            <a:ext cx="12192000" cy="5825530"/>
+          </a:xfrm>
+        </p:spPr>
+        <p:txBody>
+          <a:bodyPr/>
+          <a:lstStyle/>
+          <a:p>
+            <a:r>
+              <a:rPr lang="en-US" altLang="ko-KR" dirty="0" smtClean="0"/>
+              <a:t>Controller Service Repository Pattern </a:t>
+            </a:r>
+            <a:r>
+              <a:rPr lang="ko-KR" altLang="en-US" dirty="0" smtClean="0"/>
+              <a:t>적용</a:t>
+            </a:r>
+            <a:endParaRPr lang="en-US" altLang="ko-KR" dirty="0" smtClean="0"/>
+          </a:p>
+          <a:p>
+            <a:r>
+              <a:rPr lang="en-US" altLang="ko-KR" dirty="0" err="1" smtClean="0"/>
+              <a:t>Postgre</a:t>
+            </a:r>
+            <a:r>
+              <a:rPr lang="en-US" altLang="ko-KR" dirty="0" smtClean="0"/>
+              <a:t> DB Connection</a:t>
+            </a:r>
+          </a:p>
+          <a:p>
+            <a:r>
+              <a:rPr lang="en-US" altLang="ko-KR" dirty="0" err="1" smtClean="0"/>
+              <a:t>Redis</a:t>
+            </a:r>
+            <a:r>
+              <a:rPr lang="en-US" altLang="ko-KR" dirty="0" smtClean="0"/>
+              <a:t> Connection / Subscribe</a:t>
+            </a:r>
+          </a:p>
+          <a:p>
+            <a:r>
+              <a:rPr lang="en-US" altLang="ko-KR" dirty="0" err="1" smtClean="0"/>
+              <a:t>Redis</a:t>
+            </a:r>
+            <a:r>
+              <a:rPr lang="en-US" altLang="ko-KR" dirty="0" smtClean="0"/>
+              <a:t> Sentinel -&gt; Master </a:t>
+            </a:r>
+            <a:r>
+              <a:rPr lang="ko-KR" altLang="en-US" dirty="0" smtClean="0"/>
+              <a:t>를 따라가도록 적용</a:t>
+            </a:r>
+            <a:r>
+              <a:rPr lang="en-US" altLang="ko-KR" dirty="0" smtClean="0"/>
+              <a:t>.</a:t>
+            </a:r>
+          </a:p>
+          <a:p>
+            <a:r>
+              <a:rPr lang="en-US" altLang="ko-KR" dirty="0" smtClean="0"/>
+              <a:t>Proxy Master </a:t>
+            </a:r>
+            <a:r>
+              <a:rPr lang="ko-KR" altLang="en-US" dirty="0" smtClean="0"/>
+              <a:t>상태 확인</a:t>
+            </a:r>
+            <a:r>
+              <a:rPr lang="en-US" altLang="ko-KR" dirty="0" smtClean="0"/>
+              <a:t>.</a:t>
+            </a:r>
+          </a:p>
+          <a:p>
+            <a:endParaRPr lang="en-US" altLang="ko-KR" dirty="0"/>
+          </a:p>
+        </p:txBody>
+      </p:sp>
+    </p:spTree>
+    <p:extLst>
+      <p:ext uri="{BB962C8B-B14F-4D97-AF65-F5344CB8AC3E}">
+        <p14:creationId xmlns:p14="http://schemas.microsoft.com/office/powerpoint/2010/main" val="3060246974"/>
+      </p:ext>
+    </p:extLst>
+  </p:cSld>
+  <p:clrMapOvr>
+    <a:masterClrMapping/>
+  </p:clrMapOvr>
+  <p:timing>
+    <p:tnLst>
+      <p:par>
+        <p:cTn id="1" dur="indefinite" restart="never" nodeType="tmRoot"/>
+      </p:par>
+    </p:tnLst>
+  </p:timing>
+</p:sld>
+</file>
+
+<file path=ppt/slides/slide4.xml><?xml version="1.0" encoding="utf-8"?>
+<p:sld xmlns:a="http://schemas.openxmlformats.org/drawingml/2006/main" xmlns:r="http://schemas.openxmlformats.org/officeDocument/2006/relationships" xmlns:p="http://schemas.openxmlformats.org/presentationml/2006/main">
+  <p:cSld>
+    <p:spTree>
+      <p:nvGrpSpPr>
+        <p:cNvPr id="1" name=""/>
+        <p:cNvGrpSpPr/>
+        <p:nvPr/>
+      </p:nvGrpSpPr>
+      <p:grpSpPr>
+        <a:xfrm>
+          <a:off x="0" y="0"/>
+          <a:ext cx="0" cy="0"/>
+          <a:chOff x="0" y="0"/>
+          <a:chExt cx="0" cy="0"/>
+        </a:xfrm>
+      </p:grpSpPr>
+      <p:sp>
+        <p:nvSpPr>
+          <p:cNvPr id="2" name="제목 1"/>
+          <p:cNvSpPr>
+            <a:spLocks noGrp="1"/>
+          </p:cNvSpPr>
+          <p:nvPr>
+            <p:ph type="title"/>
+          </p:nvPr>
+        </p:nvSpPr>
+        <p:spPr>
+          <a:xfrm>
+            <a:off x="0" y="-1"/>
+            <a:ext cx="12192000" cy="1032470"/>
+          </a:xfrm>
+        </p:spPr>
+        <p:txBody>
+          <a:bodyPr/>
+          <a:lstStyle/>
+          <a:p>
+            <a:r>
+              <a:rPr lang="en-US" altLang="ko-KR" b="1" dirty="0" smtClean="0"/>
+              <a:t> </a:t>
+            </a:r>
+            <a:r>
+              <a:rPr lang="en-US" altLang="ko-KR" b="1" dirty="0"/>
+              <a:t>Problem solution</a:t>
+            </a:r>
+            <a:endParaRPr lang="ko-KR" altLang="en-US" dirty="0"/>
+          </a:p>
+        </p:txBody>
+      </p:sp>
+      <p:sp>
+        <p:nvSpPr>
+          <p:cNvPr id="3" name="내용 개체 틀 2"/>
+          <p:cNvSpPr>
+            <a:spLocks noGrp="1"/>
+          </p:cNvSpPr>
+          <p:nvPr>
+            <p:ph idx="1"/>
+          </p:nvPr>
+        </p:nvSpPr>
+        <p:spPr>
+          <a:xfrm>
+            <a:off x="0" y="1032470"/>
+            <a:ext cx="12192000" cy="5825530"/>
+          </a:xfrm>
+        </p:spPr>
+        <p:txBody>
+          <a:bodyPr>
+            <a:normAutofit lnSpcReduction="10000"/>
+          </a:bodyPr>
+          <a:lstStyle/>
+          <a:p>
+            <a:r>
+              <a:rPr lang="en-US" altLang="ko-KR" dirty="0" err="1" smtClean="0"/>
+              <a:t>Deamon</a:t>
+            </a:r>
+            <a:r>
+              <a:rPr lang="en-US" altLang="ko-KR" dirty="0" smtClean="0"/>
+              <a:t> </a:t>
+            </a:r>
+            <a:r>
+              <a:rPr lang="ko-KR" altLang="en-US" dirty="0" smtClean="0"/>
+              <a:t>형식의 </a:t>
+            </a:r>
+            <a:r>
+              <a:rPr lang="en-US" altLang="ko-KR" dirty="0" smtClean="0"/>
+              <a:t>Service </a:t>
+            </a:r>
+            <a:r>
+              <a:rPr lang="ko-KR" altLang="en-US" dirty="0" smtClean="0"/>
+              <a:t>분리</a:t>
+            </a:r>
+            <a:r>
+              <a:rPr lang="en-US" altLang="ko-KR" dirty="0" smtClean="0"/>
+              <a:t>.</a:t>
+            </a:r>
+          </a:p>
+          <a:p>
+            <a:pPr marL="0" indent="0">
+              <a:buNone/>
+            </a:pPr>
+            <a:r>
+              <a:rPr lang="en-US" altLang="ko-KR" dirty="0" smtClean="0"/>
+              <a:t>  </a:t>
+            </a:r>
+            <a:r>
+              <a:rPr lang="en-US" altLang="ko-KR" dirty="0" smtClean="0"/>
+              <a:t>-&gt; </a:t>
+            </a:r>
+            <a:r>
+              <a:rPr lang="en-US" altLang="ko-KR" dirty="0" err="1" smtClean="0"/>
+              <a:t>Task.Run</a:t>
+            </a:r>
+            <a:r>
+              <a:rPr lang="en-US" altLang="ko-KR" dirty="0" smtClean="0"/>
+              <a:t> </a:t>
+            </a:r>
+            <a:r>
+              <a:rPr lang="ko-KR" altLang="en-US" dirty="0" smtClean="0"/>
+              <a:t>으로 각 </a:t>
+            </a:r>
+            <a:r>
+              <a:rPr lang="ko-KR" altLang="en-US" dirty="0" err="1" smtClean="0"/>
+              <a:t>메소드를</a:t>
+            </a:r>
+            <a:r>
+              <a:rPr lang="ko-KR" altLang="en-US" dirty="0" smtClean="0"/>
+              <a:t> 실행 시키는 방식 대신 </a:t>
+            </a:r>
+            <a:r>
+              <a:rPr lang="en-US" altLang="ko-KR" dirty="0" err="1" smtClean="0"/>
+              <a:t>BackGroundService</a:t>
+            </a:r>
+            <a:r>
+              <a:rPr lang="en-US" altLang="ko-KR" dirty="0" smtClean="0"/>
+              <a:t> </a:t>
+            </a:r>
+            <a:r>
+              <a:rPr lang="ko-KR" altLang="en-US" dirty="0" smtClean="0"/>
+              <a:t>기반 수집 서비스 등록 하도록 변경</a:t>
+            </a:r>
+            <a:r>
+              <a:rPr lang="en-US" altLang="ko-KR" dirty="0" smtClean="0"/>
+              <a:t>.</a:t>
+            </a:r>
+          </a:p>
+          <a:p>
+            <a:pPr marL="0" indent="0">
+              <a:buNone/>
+            </a:pPr>
+            <a:r>
+              <a:rPr lang="en-US" altLang="ko-KR" dirty="0"/>
+              <a:t> </a:t>
+            </a:r>
+            <a:r>
+              <a:rPr lang="en-US" altLang="ko-KR" dirty="0" smtClean="0"/>
+              <a:t> -&gt; </a:t>
+            </a:r>
+            <a:r>
+              <a:rPr lang="en-US" altLang="ko-KR" dirty="0" err="1" smtClean="0"/>
+              <a:t>DBContext</a:t>
+            </a:r>
+            <a:r>
+              <a:rPr lang="en-US" altLang="ko-KR" dirty="0" smtClean="0"/>
+              <a:t> </a:t>
+            </a:r>
+            <a:r>
+              <a:rPr lang="ko-KR" altLang="en-US" dirty="0" smtClean="0"/>
+              <a:t>를 공유하여 사용하고 있던 코드 수정</a:t>
+            </a:r>
+            <a:r>
+              <a:rPr lang="en-US" altLang="ko-KR" dirty="0" smtClean="0"/>
+              <a:t>.</a:t>
+            </a:r>
+          </a:p>
+          <a:p>
+            <a:r>
+              <a:rPr lang="en-US" altLang="ko-KR" dirty="0" smtClean="0"/>
+              <a:t>Auto Session Recovery </a:t>
+            </a:r>
+            <a:r>
+              <a:rPr lang="ko-KR" altLang="en-US" dirty="0" smtClean="0"/>
+              <a:t>기능 개발</a:t>
+            </a:r>
+            <a:r>
+              <a:rPr lang="en-US" altLang="ko-KR" dirty="0" smtClean="0"/>
+              <a:t>.</a:t>
+            </a:r>
+          </a:p>
+          <a:p>
+            <a:pPr marL="0" indent="0">
+              <a:buNone/>
+            </a:pPr>
+            <a:r>
+              <a:rPr lang="en-US" altLang="ko-KR" dirty="0" smtClean="0"/>
+              <a:t>  -&gt;Recovery </a:t>
+            </a:r>
+            <a:r>
+              <a:rPr lang="ko-KR" altLang="en-US" dirty="0" smtClean="0"/>
+              <a:t>대상 판별</a:t>
+            </a:r>
+            <a:r>
+              <a:rPr lang="en-US" altLang="ko-KR" dirty="0" smtClean="0"/>
+              <a:t>, -&gt; </a:t>
+            </a:r>
+            <a:r>
+              <a:rPr lang="ko-KR" altLang="en-US" dirty="0" smtClean="0"/>
+              <a:t>내부 판별 기준에 따라 해당하는 장비 </a:t>
+            </a:r>
+            <a:r>
+              <a:rPr lang="ko-KR" altLang="en-US" dirty="0" err="1" smtClean="0"/>
+              <a:t>자동복구</a:t>
+            </a:r>
+            <a:r>
+              <a:rPr lang="ko-KR" altLang="en-US" dirty="0" smtClean="0"/>
+              <a:t> 수행</a:t>
+            </a:r>
+            <a:r>
+              <a:rPr lang="en-US" altLang="ko-KR" dirty="0" smtClean="0"/>
+              <a:t>.</a:t>
+            </a:r>
+          </a:p>
+          <a:p>
+            <a:r>
+              <a:rPr lang="en-US" altLang="ko-KR" dirty="0" smtClean="0"/>
+              <a:t>Abnormal History </a:t>
+            </a:r>
+            <a:r>
+              <a:rPr lang="ko-KR" altLang="en-US" dirty="0" smtClean="0"/>
+              <a:t>수집</a:t>
+            </a:r>
+            <a:r>
+              <a:rPr lang="en-US" altLang="ko-KR" dirty="0" smtClean="0"/>
+              <a:t>.</a:t>
+            </a:r>
+          </a:p>
+          <a:p>
+            <a:pPr marL="0" indent="0">
+              <a:buNone/>
+            </a:pPr>
+            <a:r>
+              <a:rPr lang="en-US" altLang="ko-KR" dirty="0" smtClean="0"/>
+              <a:t>  -&gt;Redis </a:t>
+            </a:r>
+            <a:r>
+              <a:rPr lang="ko-KR" altLang="en-US" dirty="0" smtClean="0"/>
+              <a:t>에서 주기적으로 </a:t>
+            </a:r>
+            <a:r>
+              <a:rPr lang="en-US" altLang="ko-KR" dirty="0" smtClean="0"/>
+              <a:t>Abnormal Case </a:t>
+            </a:r>
+            <a:r>
+              <a:rPr lang="ko-KR" altLang="en-US" dirty="0" smtClean="0"/>
+              <a:t>수집 후 </a:t>
+            </a:r>
+            <a:r>
+              <a:rPr lang="en-US" altLang="ko-KR" dirty="0" smtClean="0"/>
+              <a:t>DB </a:t>
+            </a:r>
+            <a:r>
+              <a:rPr lang="ko-KR" altLang="en-US" dirty="0" smtClean="0"/>
+              <a:t>저장</a:t>
+            </a:r>
+            <a:r>
+              <a:rPr lang="en-US" altLang="ko-KR" dirty="0" smtClean="0"/>
+              <a:t>.</a:t>
+            </a:r>
+          </a:p>
+          <a:p>
+            <a:pPr marL="0" indent="0">
+              <a:buNone/>
+            </a:pPr>
+            <a:r>
+              <a:rPr lang="en-US" altLang="ko-KR" dirty="0"/>
+              <a:t> </a:t>
+            </a:r>
+            <a:r>
+              <a:rPr lang="en-US" altLang="ko-KR" dirty="0" smtClean="0"/>
+              <a:t> -&gt;Abnormal Case </a:t>
+            </a:r>
+            <a:r>
+              <a:rPr lang="ko-KR" altLang="en-US" dirty="0" smtClean="0"/>
+              <a:t>발생 시 </a:t>
+            </a:r>
+            <a:r>
+              <a:rPr lang="ko-KR" altLang="en-US" dirty="0" err="1" smtClean="0"/>
+              <a:t>알람</a:t>
+            </a:r>
+            <a:r>
+              <a:rPr lang="ko-KR" altLang="en-US" dirty="0" smtClean="0"/>
+              <a:t> 발송</a:t>
+            </a:r>
+            <a:endParaRPr lang="en-US" altLang="ko-KR" dirty="0" smtClean="0"/>
+          </a:p>
+          <a:p>
+            <a:r>
+              <a:rPr lang="en-US" altLang="ko-KR" dirty="0" err="1" smtClean="0"/>
+              <a:t>SystemResource</a:t>
+            </a:r>
+            <a:r>
+              <a:rPr lang="en-US" altLang="ko-KR" dirty="0" smtClean="0"/>
+              <a:t> </a:t>
+            </a:r>
+            <a:r>
+              <a:rPr lang="ko-KR" altLang="en-US" dirty="0" smtClean="0"/>
+              <a:t>수집</a:t>
+            </a:r>
+            <a:r>
+              <a:rPr lang="en-US" altLang="ko-KR" dirty="0" smtClean="0"/>
+              <a:t>.</a:t>
+            </a:r>
+          </a:p>
+          <a:p>
+            <a:pPr marL="0" indent="0">
+              <a:buNone/>
+            </a:pPr>
+            <a:r>
+              <a:rPr lang="en-US" altLang="ko-KR" dirty="0" smtClean="0"/>
+              <a:t>  -&gt;Redis </a:t>
+            </a:r>
+            <a:r>
+              <a:rPr lang="ko-KR" altLang="en-US" dirty="0" smtClean="0"/>
+              <a:t>에서 주기적으로 </a:t>
+            </a:r>
+            <a:r>
+              <a:rPr lang="en-US" altLang="ko-KR" dirty="0" smtClean="0"/>
+              <a:t>System Resource </a:t>
+            </a:r>
+            <a:r>
+              <a:rPr lang="ko-KR" altLang="en-US" dirty="0" smtClean="0"/>
+              <a:t>수집 후 </a:t>
+            </a:r>
+            <a:r>
+              <a:rPr lang="en-US" altLang="ko-KR" dirty="0" smtClean="0"/>
+              <a:t>DB </a:t>
+            </a:r>
+            <a:r>
+              <a:rPr lang="ko-KR" altLang="en-US" dirty="0" smtClean="0"/>
+              <a:t>저장</a:t>
+            </a:r>
+            <a:r>
+              <a:rPr lang="en-US" altLang="ko-KR" dirty="0" smtClean="0"/>
+              <a:t>.</a:t>
+            </a:r>
+          </a:p>
+        </p:txBody>
+      </p:sp>
+    </p:spTree>
+    <p:extLst>
+      <p:ext uri="{BB962C8B-B14F-4D97-AF65-F5344CB8AC3E}">
+        <p14:creationId xmlns:p14="http://schemas.microsoft.com/office/powerpoint/2010/main" val="3078247629"/>
+      </p:ext>
+    </p:extLst>
+  </p:cSld>
+  <p:clrMapOvr>
+    <a:masterClrMapping/>
+  </p:clrMapOvr>
+  <p:timing>
+    <p:tnLst>
+      <p:par>
+        <p:cTn id="1" dur="indefinite" restart="never" nodeType="tmRoot"/>
+      </p:par>
+    </p:tnLst>
+  </p:timing>
+</p:sld>
+</file>
+
+<file path=ppt/slides/slide5.xml><?xml version="1.0" encoding="utf-8"?>
+<p:sld xmlns:a="http://schemas.openxmlformats.org/drawingml/2006/main" xmlns:r="http://schemas.openxmlformats.org/officeDocument/2006/relationships" xmlns:p="http://schemas.openxmlformats.org/presentationml/2006/main">
+  <p:cSld>
+    <p:spTree>
+      <p:nvGrpSpPr>
+        <p:cNvPr id="1" name=""/>
+        <p:cNvGrpSpPr/>
+        <p:nvPr/>
+      </p:nvGrpSpPr>
+      <p:grpSpPr>
+        <a:xfrm>
+          <a:off x="0" y="0"/>
+          <a:ext cx="0" cy="0"/>
+          <a:chOff x="0" y="0"/>
+          <a:chExt cx="0" cy="0"/>
+        </a:xfrm>
+      </p:grpSpPr>
+      <p:sp>
+        <p:nvSpPr>
+          <p:cNvPr id="2" name="제목 1"/>
+          <p:cNvSpPr>
+            <a:spLocks noGrp="1"/>
+          </p:cNvSpPr>
+          <p:nvPr>
+            <p:ph type="title"/>
+          </p:nvPr>
+        </p:nvSpPr>
+        <p:spPr>
+          <a:xfrm>
             <a:off x="0" y="18091"/>
             <a:ext cx="12192000" cy="881301"/>
           </a:xfrm>
         </p:spPr>
         <p:txBody>
           <a:bodyPr>
-            <a:normAutofit/>
+            <a:normAutofit fontScale="90000"/>
           </a:bodyPr>
           <a:lstStyle/>
           <a:p>
@@ -3857,19 +4981,15 @@
             </a:r>
             <a:r>
               <a:rPr lang="en-US" altLang="ko-KR" b="1" dirty="0" smtClean="0"/>
-              <a:t>- </a:t>
-            </a:r>
-            <a:r>
-              <a:rPr lang="en-US" altLang="ko-KR" sz="3200" dirty="0"/>
-              <a:t>Proxy Master </a:t>
-            </a:r>
-            <a:r>
-              <a:rPr lang="ko-KR" altLang="en-US" sz="3200" dirty="0"/>
-              <a:t>상태 확인</a:t>
-            </a:r>
-            <a:r>
-              <a:rPr lang="en-US" altLang="ko-KR" sz="3200" dirty="0" smtClean="0"/>
-              <a:t>.</a:t>
+              <a:t>-</a:t>
+            </a:r>
+            <a:r>
+              <a:rPr lang="en-US" altLang="ko-KR" sz="3100" dirty="0"/>
+              <a:t>Controller Service Repository Pattern </a:t>
+            </a:r>
+            <a:r>
+              <a:rPr lang="ko-KR" altLang="en-US" sz="3100" dirty="0" smtClean="0"/>
+              <a:t>적용</a:t>
             </a:r>
             <a:endParaRPr lang="ko-KR" altLang="en-US" sz="3100" dirty="0"/>
           </a:p>
@@ -3885,8 +5005,8 @@
         </p:nvSpPr>
         <p:spPr>
           <a:xfrm>
-            <a:off x="0" y="803868"/>
-            <a:ext cx="12192000" cy="6054132"/>
+            <a:off x="0" y="1032470"/>
+            <a:ext cx="12192000" cy="5825530"/>
           </a:xfrm>
           <a:prstGeom prst="rect">
             <a:avLst/>
@@ -4063,1224 +5183,6 @@
           <a:p>
             <a:r>
               <a:rPr lang="en-US" altLang="ko-KR" dirty="0" smtClean="0"/>
-              <a:t>Proxy Socket </a:t>
-            </a:r>
-            <a:r>
-              <a:rPr lang="ko-KR" altLang="en-US" dirty="0" smtClean="0"/>
-              <a:t>연결 후 </a:t>
-            </a:r>
-            <a:r>
-              <a:rPr lang="en-US" altLang="ko-KR" dirty="0" smtClean="0"/>
-              <a:t>Command </a:t>
-            </a:r>
-            <a:r>
-              <a:rPr lang="ko-KR" altLang="en-US" dirty="0" smtClean="0"/>
-              <a:t>로 데이터 가져오도록 함</a:t>
-            </a:r>
-            <a:r>
-              <a:rPr lang="en-US" altLang="ko-KR" dirty="0" smtClean="0"/>
-              <a:t>.</a:t>
-            </a:r>
-          </a:p>
-          <a:p>
-            <a:r>
-              <a:rPr lang="ko-KR" altLang="en-US" dirty="0" smtClean="0"/>
-              <a:t>해당 </a:t>
-            </a:r>
-            <a:r>
-              <a:rPr lang="en-US" altLang="ko-KR" dirty="0" smtClean="0"/>
-              <a:t>MAS </a:t>
-            </a:r>
-            <a:r>
-              <a:rPr lang="ko-KR" altLang="en-US" dirty="0" smtClean="0"/>
-              <a:t>의 </a:t>
-            </a:r>
-            <a:r>
-              <a:rPr lang="en-US" altLang="ko-KR" dirty="0" smtClean="0"/>
-              <a:t>IP </a:t>
-            </a:r>
-            <a:r>
-              <a:rPr lang="ko-KR" altLang="en-US" dirty="0" smtClean="0"/>
-              <a:t>주소가 </a:t>
-            </a:r>
-            <a:r>
-              <a:rPr lang="en-US" altLang="ko-KR" dirty="0" smtClean="0"/>
-              <a:t>Proxy Master </a:t>
-            </a:r>
-            <a:r>
-              <a:rPr lang="ko-KR" altLang="en-US" dirty="0" smtClean="0"/>
-              <a:t>주소 를 가지고 있는지 확인</a:t>
-            </a:r>
-            <a:r>
-              <a:rPr lang="en-US" altLang="ko-KR" dirty="0" smtClean="0"/>
-              <a:t>.</a:t>
-            </a:r>
-            <a:endParaRPr lang="en-US" altLang="ko-KR" dirty="0" smtClean="0"/>
-          </a:p>
-          <a:p>
-            <a:endParaRPr lang="en-US" altLang="ko-KR" dirty="0"/>
-          </a:p>
-          <a:p>
-            <a:endParaRPr lang="en-US" altLang="ko-KR" dirty="0" smtClean="0"/>
-          </a:p>
-          <a:p>
-            <a:endParaRPr lang="en-US" altLang="ko-KR" dirty="0"/>
-          </a:p>
-          <a:p>
-            <a:endParaRPr lang="en-US" altLang="ko-KR" dirty="0" smtClean="0"/>
-          </a:p>
-          <a:p>
-            <a:endParaRPr lang="en-US" altLang="ko-KR" dirty="0"/>
-          </a:p>
-          <a:p>
-            <a:r>
-              <a:rPr lang="en-US" altLang="ko-KR" dirty="0" smtClean="0"/>
-              <a:t>                                     Proxy </a:t>
-            </a:r>
-            <a:r>
-              <a:rPr lang="en-US" altLang="ko-KR" dirty="0" err="1" smtClean="0"/>
-              <a:t>Url</a:t>
-            </a:r>
-            <a:r>
-              <a:rPr lang="en-US" altLang="ko-KR" dirty="0" smtClean="0"/>
-              <a:t> </a:t>
-            </a:r>
-            <a:r>
-              <a:rPr lang="ko-KR" altLang="en-US" dirty="0" smtClean="0"/>
-              <a:t>로 </a:t>
-            </a:r>
-            <a:r>
-              <a:rPr lang="en-US" altLang="ko-KR" dirty="0" smtClean="0"/>
-              <a:t>http </a:t>
-            </a:r>
-            <a:r>
-              <a:rPr lang="ko-KR" altLang="en-US" dirty="0" smtClean="0"/>
-              <a:t>통신으로 데이터 받아 옴</a:t>
-            </a:r>
-            <a:r>
-              <a:rPr lang="en-US" altLang="ko-KR" dirty="0"/>
-              <a:t>.</a:t>
-            </a:r>
-            <a:endParaRPr lang="en-US" altLang="ko-KR" dirty="0" smtClean="0"/>
-          </a:p>
-        </p:txBody>
-      </p:sp>
-      <p:pic>
-        <p:nvPicPr>
-          <p:cNvPr id="3" name="그림 2"/>
-          <p:cNvPicPr>
-            <a:picLocks noChangeAspect="1"/>
-          </p:cNvPicPr>
-          <p:nvPr/>
-        </p:nvPicPr>
-        <p:blipFill>
-          <a:blip r:embed="rId2"/>
-          <a:stretch>
-            <a:fillRect/>
-          </a:stretch>
-        </p:blipFill>
-        <p:spPr>
-          <a:xfrm>
-            <a:off x="70058" y="2147080"/>
-            <a:ext cx="6839905" cy="1638529"/>
-          </a:xfrm>
-          <a:prstGeom prst="rect">
-            <a:avLst/>
-          </a:prstGeom>
-        </p:spPr>
-      </p:pic>
-      <p:pic>
-        <p:nvPicPr>
-          <p:cNvPr id="6" name="그림 5"/>
-          <p:cNvPicPr>
-            <a:picLocks noChangeAspect="1"/>
-          </p:cNvPicPr>
-          <p:nvPr/>
-        </p:nvPicPr>
-        <p:blipFill>
-          <a:blip r:embed="rId3"/>
-          <a:stretch>
-            <a:fillRect/>
-          </a:stretch>
-        </p:blipFill>
-        <p:spPr>
-          <a:xfrm>
-            <a:off x="0" y="3830934"/>
-            <a:ext cx="4563112" cy="2981741"/>
-          </a:xfrm>
-          <a:prstGeom prst="rect">
-            <a:avLst/>
-          </a:prstGeom>
-        </p:spPr>
-      </p:pic>
-      <p:pic>
-        <p:nvPicPr>
-          <p:cNvPr id="8" name="그림 7"/>
-          <p:cNvPicPr>
-            <a:picLocks noChangeAspect="1"/>
-          </p:cNvPicPr>
-          <p:nvPr/>
-        </p:nvPicPr>
-        <p:blipFill>
-          <a:blip r:embed="rId4"/>
-          <a:stretch>
-            <a:fillRect/>
-          </a:stretch>
-        </p:blipFill>
-        <p:spPr>
-          <a:xfrm>
-            <a:off x="4910348" y="4831198"/>
-            <a:ext cx="6325483" cy="1981477"/>
-          </a:xfrm>
-          <a:prstGeom prst="rect">
-            <a:avLst/>
-          </a:prstGeom>
-        </p:spPr>
-      </p:pic>
-      <p:pic>
-        <p:nvPicPr>
-          <p:cNvPr id="4" name="그림 3"/>
-          <p:cNvPicPr>
-            <a:picLocks noChangeAspect="1"/>
-          </p:cNvPicPr>
-          <p:nvPr/>
-        </p:nvPicPr>
-        <p:blipFill>
-          <a:blip r:embed="rId5"/>
-          <a:stretch>
-            <a:fillRect/>
-          </a:stretch>
-        </p:blipFill>
-        <p:spPr>
-          <a:xfrm>
-            <a:off x="70058" y="1749281"/>
-            <a:ext cx="7116168" cy="352474"/>
-          </a:xfrm>
-          <a:prstGeom prst="rect">
-            <a:avLst/>
-          </a:prstGeom>
-        </p:spPr>
-      </p:pic>
-    </p:spTree>
-    <p:extLst>
-      <p:ext uri="{BB962C8B-B14F-4D97-AF65-F5344CB8AC3E}">
-        <p14:creationId xmlns:p14="http://schemas.microsoft.com/office/powerpoint/2010/main" val="1426452746"/>
-      </p:ext>
-    </p:extLst>
-  </p:cSld>
-  <p:clrMapOvr>
-    <a:masterClrMapping/>
-  </p:clrMapOvr>
-  <p:timing>
-    <p:tnLst>
-      <p:par>
-        <p:cTn id="1" dur="indefinite" restart="never" nodeType="tmRoot"/>
-      </p:par>
-    </p:tnLst>
-  </p:timing>
-</p:sld>
-</file>
-
-<file path=ppt/slides/slide11.xml><?xml version="1.0" encoding="utf-8"?>
-<p:sld xmlns:a="http://schemas.openxmlformats.org/drawingml/2006/main" xmlns:r="http://schemas.openxmlformats.org/officeDocument/2006/relationships" xmlns:p="http://schemas.openxmlformats.org/presentationml/2006/main">
-  <p:cSld>
-    <p:spTree>
-      <p:nvGrpSpPr>
-        <p:cNvPr id="1" name=""/>
-        <p:cNvGrpSpPr/>
-        <p:nvPr/>
-      </p:nvGrpSpPr>
-      <p:grpSpPr>
-        <a:xfrm>
-          <a:off x="0" y="0"/>
-          <a:ext cx="0" cy="0"/>
-          <a:chOff x="0" y="0"/>
-          <a:chExt cx="0" cy="0"/>
-        </a:xfrm>
-      </p:grpSpPr>
-      <p:sp>
-        <p:nvSpPr>
-          <p:cNvPr id="2" name="제목 1"/>
-          <p:cNvSpPr>
-            <a:spLocks noGrp="1"/>
-          </p:cNvSpPr>
-          <p:nvPr>
-            <p:ph type="title"/>
-          </p:nvPr>
-        </p:nvSpPr>
-        <p:spPr>
-          <a:xfrm>
-            <a:off x="0" y="0"/>
-            <a:ext cx="12192000" cy="1457011"/>
-          </a:xfrm>
-        </p:spPr>
-        <p:txBody>
-          <a:bodyPr/>
-          <a:lstStyle/>
-          <a:p>
-            <a:r>
-              <a:rPr lang="en-US" altLang="ko-KR" b="1" dirty="0" smtClean="0"/>
-              <a:t> Result </a:t>
-            </a:r>
-            <a:r>
-              <a:rPr lang="en-US" altLang="ko-KR" b="1" dirty="0"/>
-              <a:t>Notes</a:t>
-            </a:r>
-            <a:endParaRPr lang="ko-KR" altLang="en-US" dirty="0"/>
-          </a:p>
-        </p:txBody>
-      </p:sp>
-      <p:sp>
-        <p:nvSpPr>
-          <p:cNvPr id="3" name="내용 개체 틀 2"/>
-          <p:cNvSpPr>
-            <a:spLocks noGrp="1"/>
-          </p:cNvSpPr>
-          <p:nvPr>
-            <p:ph idx="1"/>
-          </p:nvPr>
-        </p:nvSpPr>
-        <p:spPr>
-          <a:xfrm>
-            <a:off x="0" y="1245996"/>
-            <a:ext cx="11353800" cy="4941015"/>
-          </a:xfrm>
-        </p:spPr>
-        <p:txBody>
-          <a:bodyPr/>
-          <a:lstStyle/>
-          <a:p>
-            <a:r>
-              <a:rPr lang="ko-KR" altLang="en-US" dirty="0" smtClean="0"/>
-              <a:t>통합 </a:t>
-            </a:r>
-            <a:r>
-              <a:rPr lang="en-US" altLang="ko-KR" dirty="0" smtClean="0"/>
-              <a:t>UI </a:t>
-            </a:r>
-            <a:r>
-              <a:rPr lang="ko-KR" altLang="en-US" dirty="0" smtClean="0"/>
-              <a:t>하나로 </a:t>
-            </a:r>
-            <a:r>
-              <a:rPr lang="en-US" altLang="ko-KR" dirty="0" smtClean="0"/>
-              <a:t>EDA Operation </a:t>
-            </a:r>
-            <a:r>
-              <a:rPr lang="ko-KR" altLang="en-US" dirty="0" smtClean="0"/>
-              <a:t>수행 가능</a:t>
-            </a:r>
-            <a:r>
-              <a:rPr lang="en-US" altLang="ko-KR" dirty="0" smtClean="0"/>
-              <a:t>.</a:t>
-            </a:r>
-          </a:p>
-          <a:p>
-            <a:r>
-              <a:rPr lang="ko-KR" altLang="en-US" dirty="0" smtClean="0"/>
-              <a:t>안정적인 </a:t>
-            </a:r>
-            <a:r>
-              <a:rPr lang="en-US" altLang="ko-KR" dirty="0" err="1" smtClean="0"/>
-              <a:t>Redis</a:t>
-            </a:r>
-            <a:r>
-              <a:rPr lang="en-US" altLang="ko-KR" dirty="0" smtClean="0"/>
-              <a:t> </a:t>
-            </a:r>
-            <a:r>
-              <a:rPr lang="ko-KR" altLang="en-US" dirty="0" smtClean="0"/>
-              <a:t>통신 가능</a:t>
-            </a:r>
-            <a:endParaRPr lang="en-US" altLang="ko-KR" dirty="0" smtClean="0"/>
-          </a:p>
-          <a:p>
-            <a:r>
-              <a:rPr lang="en-US" altLang="ko-KR" dirty="0" err="1" smtClean="0"/>
-              <a:t>DBType</a:t>
-            </a:r>
-            <a:r>
-              <a:rPr lang="en-US" altLang="ko-KR" dirty="0" smtClean="0"/>
-              <a:t> </a:t>
-            </a:r>
-            <a:r>
-              <a:rPr lang="ko-KR" altLang="en-US" dirty="0" smtClean="0"/>
-              <a:t>에 따른 </a:t>
-            </a:r>
-            <a:r>
-              <a:rPr lang="en-US" altLang="ko-KR" dirty="0" err="1" smtClean="0"/>
-              <a:t>Swich</a:t>
-            </a:r>
-            <a:r>
-              <a:rPr lang="en-US" altLang="ko-KR" dirty="0" smtClean="0"/>
-              <a:t> </a:t>
-            </a:r>
-            <a:r>
-              <a:rPr lang="ko-KR" altLang="en-US" dirty="0" smtClean="0"/>
-              <a:t>용이</a:t>
-            </a:r>
-            <a:r>
-              <a:rPr lang="en-US" altLang="ko-KR" dirty="0" smtClean="0"/>
-              <a:t>.</a:t>
-            </a:r>
-          </a:p>
-          <a:p>
-            <a:r>
-              <a:rPr lang="en-US" altLang="ko-KR" dirty="0" smtClean="0"/>
-              <a:t>Data </a:t>
-            </a:r>
-            <a:r>
-              <a:rPr lang="ko-KR" altLang="en-US" dirty="0" smtClean="0"/>
-              <a:t>끊김 없이 </a:t>
-            </a:r>
-            <a:r>
-              <a:rPr lang="en-US" altLang="ko-KR" dirty="0" smtClean="0"/>
-              <a:t>Proxy </a:t>
-            </a:r>
-            <a:r>
-              <a:rPr lang="ko-KR" altLang="en-US" dirty="0" smtClean="0"/>
-              <a:t>관리 가능</a:t>
-            </a:r>
-            <a:r>
-              <a:rPr lang="en-US" altLang="ko-KR" dirty="0" smtClean="0"/>
-              <a:t>.</a:t>
-            </a:r>
-            <a:endParaRPr lang="en-US" altLang="ko-KR" dirty="0" smtClean="0"/>
-          </a:p>
-          <a:p>
-            <a:pPr marL="0" indent="0">
-              <a:buNone/>
-            </a:pPr>
-            <a:endParaRPr lang="en-US" altLang="ko-KR" dirty="0"/>
-          </a:p>
-          <a:p>
-            <a:pPr marL="0" indent="0">
-              <a:buNone/>
-            </a:pPr>
-            <a:endParaRPr lang="en-US" altLang="ko-KR" dirty="0" smtClean="0"/>
-          </a:p>
-          <a:p>
-            <a:endParaRPr lang="ko-KR" altLang="en-US" dirty="0"/>
-          </a:p>
-        </p:txBody>
-      </p:sp>
-    </p:spTree>
-    <p:extLst>
-      <p:ext uri="{BB962C8B-B14F-4D97-AF65-F5344CB8AC3E}">
-        <p14:creationId xmlns:p14="http://schemas.microsoft.com/office/powerpoint/2010/main" val="2034695615"/>
-      </p:ext>
-    </p:extLst>
-  </p:cSld>
-  <p:clrMapOvr>
-    <a:masterClrMapping/>
-  </p:clrMapOvr>
-  <p:timing>
-    <p:tnLst>
-      <p:par>
-        <p:cTn id="1" dur="indefinite" restart="never" nodeType="tmRoot"/>
-      </p:par>
-    </p:tnLst>
-  </p:timing>
-</p:sld>
-</file>
-
-<file path=ppt/slides/slide2.xml><?xml version="1.0" encoding="utf-8"?>
-<p:sld xmlns:a="http://schemas.openxmlformats.org/drawingml/2006/main" xmlns:r="http://schemas.openxmlformats.org/officeDocument/2006/relationships" xmlns:p="http://schemas.openxmlformats.org/presentationml/2006/main">
-  <p:cSld>
-    <p:spTree>
-      <p:nvGrpSpPr>
-        <p:cNvPr id="1" name=""/>
-        <p:cNvGrpSpPr/>
-        <p:nvPr/>
-      </p:nvGrpSpPr>
-      <p:grpSpPr>
-        <a:xfrm>
-          <a:off x="0" y="0"/>
-          <a:ext cx="0" cy="0"/>
-          <a:chOff x="0" y="0"/>
-          <a:chExt cx="0" cy="0"/>
-        </a:xfrm>
-      </p:grpSpPr>
-      <p:sp>
-        <p:nvSpPr>
-          <p:cNvPr id="2" name="제목 1"/>
-          <p:cNvSpPr>
-            <a:spLocks noGrp="1"/>
-          </p:cNvSpPr>
-          <p:nvPr>
-            <p:ph type="title"/>
-          </p:nvPr>
-        </p:nvSpPr>
-        <p:spPr>
-          <a:xfrm>
-            <a:off x="0" y="0"/>
-            <a:ext cx="12192000" cy="1055078"/>
-          </a:xfrm>
-        </p:spPr>
-        <p:txBody>
-          <a:bodyPr/>
-          <a:lstStyle/>
-          <a:p>
-            <a:r>
-              <a:rPr lang="en-US" altLang="ko-KR" b="1" dirty="0" smtClean="0"/>
-              <a:t> Introduction</a:t>
-            </a:r>
-            <a:endParaRPr lang="ko-KR" altLang="en-US" dirty="0"/>
-          </a:p>
-        </p:txBody>
-      </p:sp>
-      <p:sp>
-        <p:nvSpPr>
-          <p:cNvPr id="3" name="내용 개체 틀 2"/>
-          <p:cNvSpPr>
-            <a:spLocks noGrp="1"/>
-          </p:cNvSpPr>
-          <p:nvPr>
-            <p:ph idx="1"/>
-          </p:nvPr>
-        </p:nvSpPr>
-        <p:spPr>
-          <a:xfrm>
-            <a:off x="0" y="1055078"/>
-            <a:ext cx="12192000" cy="5802922"/>
-          </a:xfrm>
-        </p:spPr>
-        <p:txBody>
-          <a:bodyPr/>
-          <a:lstStyle/>
-          <a:p>
-            <a:r>
-              <a:rPr lang="en-US" altLang="ko-KR" dirty="0" smtClean="0"/>
-              <a:t>EDA </a:t>
-            </a:r>
-            <a:r>
-              <a:rPr lang="ko-KR" altLang="en-US" dirty="0" smtClean="0"/>
-              <a:t>전반적인 통합 </a:t>
-            </a:r>
-            <a:r>
-              <a:rPr lang="en-US" altLang="ko-KR" dirty="0" smtClean="0"/>
-              <a:t>UI </a:t>
-            </a:r>
-            <a:r>
-              <a:rPr lang="ko-KR" altLang="en-US" dirty="0" smtClean="0"/>
-              <a:t>시스템 </a:t>
-            </a:r>
-            <a:r>
-              <a:rPr lang="ko-KR" altLang="en-US" dirty="0" smtClean="0"/>
-              <a:t>필요</a:t>
-            </a:r>
-            <a:r>
-              <a:rPr lang="en-US" altLang="ko-KR" dirty="0" smtClean="0"/>
-              <a:t>.</a:t>
-            </a:r>
-          </a:p>
-          <a:p>
-            <a:r>
-              <a:rPr lang="en-US" altLang="ko-KR" dirty="0" smtClean="0"/>
-              <a:t>Rest API </a:t>
-            </a:r>
-            <a:r>
-              <a:rPr lang="ko-KR" altLang="en-US" dirty="0" smtClean="0"/>
-              <a:t>통신</a:t>
-            </a:r>
-            <a:endParaRPr lang="en-US" altLang="ko-KR" dirty="0" smtClean="0"/>
-          </a:p>
-          <a:p>
-            <a:r>
-              <a:rPr lang="en-US" altLang="ko-KR" dirty="0" smtClean="0"/>
-              <a:t>UI(Client) </a:t>
-            </a:r>
-            <a:r>
-              <a:rPr lang="ko-KR" altLang="en-US" dirty="0" smtClean="0"/>
-              <a:t>와 </a:t>
-            </a:r>
-            <a:r>
-              <a:rPr lang="en-US" altLang="ko-KR" dirty="0" smtClean="0"/>
-              <a:t>EQ, Consumer, DB, </a:t>
-            </a:r>
-            <a:r>
-              <a:rPr lang="en-US" altLang="ko-KR" dirty="0" err="1" smtClean="0"/>
-              <a:t>Redis</a:t>
-            </a:r>
-            <a:r>
-              <a:rPr lang="en-US" altLang="ko-KR" dirty="0" smtClean="0"/>
-              <a:t> </a:t>
-            </a:r>
-            <a:r>
-              <a:rPr lang="ko-KR" altLang="en-US" dirty="0" smtClean="0"/>
-              <a:t>를 연결 하는 </a:t>
-            </a:r>
-            <a:r>
-              <a:rPr lang="en-US" altLang="ko-KR" dirty="0" smtClean="0"/>
-              <a:t>Server </a:t>
-            </a:r>
-            <a:r>
-              <a:rPr lang="ko-KR" altLang="en-US" dirty="0" smtClean="0"/>
-              <a:t>프로그램 필요</a:t>
-            </a:r>
-            <a:r>
-              <a:rPr lang="en-US" altLang="ko-KR" dirty="0" smtClean="0"/>
-              <a:t>.</a:t>
-            </a:r>
-          </a:p>
-          <a:p>
-            <a:r>
-              <a:rPr lang="en-US" altLang="ko-KR" dirty="0" smtClean="0"/>
-              <a:t>VIP </a:t>
-            </a:r>
-            <a:r>
-              <a:rPr lang="ko-KR" altLang="en-US" dirty="0" smtClean="0"/>
-              <a:t>를 통해 </a:t>
-            </a:r>
-            <a:r>
-              <a:rPr lang="en-US" altLang="ko-KR" dirty="0" smtClean="0"/>
-              <a:t>Fail Over </a:t>
-            </a:r>
-            <a:r>
-              <a:rPr lang="ko-KR" altLang="en-US" dirty="0" smtClean="0"/>
-              <a:t>기능 포함</a:t>
-            </a:r>
-            <a:r>
-              <a:rPr lang="en-US" altLang="ko-KR" dirty="0"/>
-              <a:t>.</a:t>
-            </a:r>
-            <a:endParaRPr lang="en-US" altLang="ko-KR" dirty="0" smtClean="0"/>
-          </a:p>
-        </p:txBody>
-      </p:sp>
-    </p:spTree>
-    <p:extLst>
-      <p:ext uri="{BB962C8B-B14F-4D97-AF65-F5344CB8AC3E}">
-        <p14:creationId xmlns:p14="http://schemas.microsoft.com/office/powerpoint/2010/main" val="3312636876"/>
-      </p:ext>
-    </p:extLst>
-  </p:cSld>
-  <p:clrMapOvr>
-    <a:masterClrMapping/>
-  </p:clrMapOvr>
-  <p:timing>
-    <p:tnLst>
-      <p:par>
-        <p:cTn id="1" dur="indefinite" restart="never" nodeType="tmRoot"/>
-      </p:par>
-    </p:tnLst>
-  </p:timing>
-</p:sld>
-</file>
-
-<file path=ppt/slides/slide3.xml><?xml version="1.0" encoding="utf-8"?>
-<p:sld xmlns:a="http://schemas.openxmlformats.org/drawingml/2006/main" xmlns:r="http://schemas.openxmlformats.org/officeDocument/2006/relationships" xmlns:p="http://schemas.openxmlformats.org/presentationml/2006/main">
-  <p:cSld>
-    <p:spTree>
-      <p:nvGrpSpPr>
-        <p:cNvPr id="1" name=""/>
-        <p:cNvGrpSpPr/>
-        <p:nvPr/>
-      </p:nvGrpSpPr>
-      <p:grpSpPr>
-        <a:xfrm>
-          <a:off x="0" y="0"/>
-          <a:ext cx="0" cy="0"/>
-          <a:chOff x="0" y="0"/>
-          <a:chExt cx="0" cy="0"/>
-        </a:xfrm>
-      </p:grpSpPr>
-      <p:pic>
-        <p:nvPicPr>
-          <p:cNvPr id="6" name="그림 5"/>
-          <p:cNvPicPr>
-            <a:picLocks noChangeAspect="1"/>
-          </p:cNvPicPr>
-          <p:nvPr/>
-        </p:nvPicPr>
-        <p:blipFill>
-          <a:blip r:embed="rId2"/>
-          <a:stretch>
-            <a:fillRect/>
-          </a:stretch>
-        </p:blipFill>
-        <p:spPr>
-          <a:xfrm>
-            <a:off x="3912" y="-5242"/>
-            <a:ext cx="12184175" cy="6868484"/>
-          </a:xfrm>
-          <a:prstGeom prst="rect">
-            <a:avLst/>
-          </a:prstGeom>
-        </p:spPr>
-      </p:pic>
-    </p:spTree>
-    <p:extLst>
-      <p:ext uri="{BB962C8B-B14F-4D97-AF65-F5344CB8AC3E}">
-        <p14:creationId xmlns:p14="http://schemas.microsoft.com/office/powerpoint/2010/main" val="2225753569"/>
-      </p:ext>
-    </p:extLst>
-  </p:cSld>
-  <p:clrMapOvr>
-    <a:masterClrMapping/>
-  </p:clrMapOvr>
-  <p:timing>
-    <p:tnLst>
-      <p:par>
-        <p:cTn id="1" dur="indefinite" restart="never" nodeType="tmRoot"/>
-      </p:par>
-    </p:tnLst>
-  </p:timing>
-</p:sld>
-</file>
-
-<file path=ppt/slides/slide4.xml><?xml version="1.0" encoding="utf-8"?>
-<p:sld xmlns:a="http://schemas.openxmlformats.org/drawingml/2006/main" xmlns:r="http://schemas.openxmlformats.org/officeDocument/2006/relationships" xmlns:p="http://schemas.openxmlformats.org/presentationml/2006/main">
-  <p:cSld>
-    <p:spTree>
-      <p:nvGrpSpPr>
-        <p:cNvPr id="1" name=""/>
-        <p:cNvGrpSpPr/>
-        <p:nvPr/>
-      </p:nvGrpSpPr>
-      <p:grpSpPr>
-        <a:xfrm>
-          <a:off x="0" y="0"/>
-          <a:ext cx="0" cy="0"/>
-          <a:chOff x="0" y="0"/>
-          <a:chExt cx="0" cy="0"/>
-        </a:xfrm>
-      </p:grpSpPr>
-      <p:sp>
-        <p:nvSpPr>
-          <p:cNvPr id="2" name="제목 1"/>
-          <p:cNvSpPr>
-            <a:spLocks noGrp="1"/>
-          </p:cNvSpPr>
-          <p:nvPr>
-            <p:ph type="title"/>
-          </p:nvPr>
-        </p:nvSpPr>
-        <p:spPr>
-          <a:xfrm>
-            <a:off x="0" y="0"/>
-            <a:ext cx="12192000" cy="924448"/>
-          </a:xfrm>
-        </p:spPr>
-        <p:txBody>
-          <a:bodyPr/>
-          <a:lstStyle/>
-          <a:p>
-            <a:r>
-              <a:rPr lang="en-US" altLang="ko-KR" b="1" dirty="0" smtClean="0"/>
-              <a:t> Problem Setup</a:t>
-            </a:r>
-            <a:endParaRPr lang="ko-KR" altLang="en-US" dirty="0"/>
-          </a:p>
-        </p:txBody>
-      </p:sp>
-      <p:sp>
-        <p:nvSpPr>
-          <p:cNvPr id="3" name="내용 개체 틀 2"/>
-          <p:cNvSpPr>
-            <a:spLocks noGrp="1"/>
-          </p:cNvSpPr>
-          <p:nvPr>
-            <p:ph idx="1"/>
-          </p:nvPr>
-        </p:nvSpPr>
-        <p:spPr>
-          <a:xfrm>
-            <a:off x="0" y="924448"/>
-            <a:ext cx="12192000" cy="5933552"/>
-          </a:xfrm>
-        </p:spPr>
-        <p:txBody>
-          <a:bodyPr/>
-          <a:lstStyle/>
-          <a:p>
-            <a:r>
-              <a:rPr lang="en-US" altLang="ko-KR" dirty="0" smtClean="0"/>
-              <a:t>API </a:t>
-            </a:r>
-            <a:r>
-              <a:rPr lang="ko-KR" altLang="en-US" dirty="0" smtClean="0"/>
-              <a:t>통신</a:t>
-            </a:r>
-            <a:r>
-              <a:rPr lang="en-US" altLang="ko-KR" dirty="0" smtClean="0"/>
-              <a:t>, </a:t>
-            </a:r>
-            <a:r>
-              <a:rPr lang="en-US" altLang="ko-KR" dirty="0" err="1" smtClean="0"/>
-              <a:t>Redis</a:t>
-            </a:r>
-            <a:r>
-              <a:rPr lang="en-US" altLang="ko-KR" dirty="0" smtClean="0"/>
-              <a:t> Pub/Sub, </a:t>
-            </a:r>
-            <a:r>
-              <a:rPr lang="en-US" altLang="ko-KR" dirty="0" err="1" smtClean="0"/>
-              <a:t>PostgreSql</a:t>
-            </a:r>
-            <a:r>
-              <a:rPr lang="en-US" altLang="ko-KR" dirty="0" smtClean="0"/>
-              <a:t> </a:t>
-            </a:r>
-            <a:r>
-              <a:rPr lang="ko-KR" altLang="en-US" dirty="0" smtClean="0"/>
-              <a:t>필요</a:t>
-            </a:r>
-            <a:r>
-              <a:rPr lang="en-US" altLang="ko-KR" dirty="0" smtClean="0"/>
-              <a:t>.</a:t>
-            </a:r>
-            <a:endParaRPr lang="en-US" altLang="ko-KR" dirty="0" smtClean="0"/>
-          </a:p>
-        </p:txBody>
-      </p:sp>
-      <p:pic>
-        <p:nvPicPr>
-          <p:cNvPr id="5" name="그림 4"/>
-          <p:cNvPicPr>
-            <a:picLocks noChangeAspect="1"/>
-          </p:cNvPicPr>
-          <p:nvPr/>
-        </p:nvPicPr>
-        <p:blipFill>
-          <a:blip r:embed="rId2"/>
-          <a:stretch>
-            <a:fillRect/>
-          </a:stretch>
-        </p:blipFill>
-        <p:spPr>
-          <a:xfrm>
-            <a:off x="120836" y="1848896"/>
-            <a:ext cx="12071164" cy="5009104"/>
-          </a:xfrm>
-          <a:prstGeom prst="rect">
-            <a:avLst/>
-          </a:prstGeom>
-        </p:spPr>
-      </p:pic>
-    </p:spTree>
-    <p:extLst>
-      <p:ext uri="{BB962C8B-B14F-4D97-AF65-F5344CB8AC3E}">
-        <p14:creationId xmlns:p14="http://schemas.microsoft.com/office/powerpoint/2010/main" val="3073345643"/>
-      </p:ext>
-    </p:extLst>
-  </p:cSld>
-  <p:clrMapOvr>
-    <a:masterClrMapping/>
-  </p:clrMapOvr>
-  <p:timing>
-    <p:tnLst>
-      <p:par>
-        <p:cTn id="1" dur="indefinite" restart="never" nodeType="tmRoot"/>
-      </p:par>
-    </p:tnLst>
-  </p:timing>
-</p:sld>
-</file>
-
-<file path=ppt/slides/slide5.xml><?xml version="1.0" encoding="utf-8"?>
-<p:sld xmlns:a="http://schemas.openxmlformats.org/drawingml/2006/main" xmlns:r="http://schemas.openxmlformats.org/officeDocument/2006/relationships" xmlns:p="http://schemas.openxmlformats.org/presentationml/2006/main">
-  <p:cSld>
-    <p:spTree>
-      <p:nvGrpSpPr>
-        <p:cNvPr id="1" name=""/>
-        <p:cNvGrpSpPr/>
-        <p:nvPr/>
-      </p:nvGrpSpPr>
-      <p:grpSpPr>
-        <a:xfrm>
-          <a:off x="0" y="0"/>
-          <a:ext cx="0" cy="0"/>
-          <a:chOff x="0" y="0"/>
-          <a:chExt cx="0" cy="0"/>
-        </a:xfrm>
-      </p:grpSpPr>
-      <p:sp>
-        <p:nvSpPr>
-          <p:cNvPr id="2" name="제목 1"/>
-          <p:cNvSpPr>
-            <a:spLocks noGrp="1"/>
-          </p:cNvSpPr>
-          <p:nvPr>
-            <p:ph type="title"/>
-          </p:nvPr>
-        </p:nvSpPr>
-        <p:spPr>
-          <a:xfrm>
-            <a:off x="0" y="-1"/>
-            <a:ext cx="12192000" cy="1032470"/>
-          </a:xfrm>
-        </p:spPr>
-        <p:txBody>
-          <a:bodyPr/>
-          <a:lstStyle/>
-          <a:p>
-            <a:r>
-              <a:rPr lang="en-US" altLang="ko-KR" b="1" dirty="0" smtClean="0"/>
-              <a:t> Scope</a:t>
-            </a:r>
-            <a:endParaRPr lang="ko-KR" altLang="en-US" dirty="0"/>
-          </a:p>
-        </p:txBody>
-      </p:sp>
-      <p:sp>
-        <p:nvSpPr>
-          <p:cNvPr id="3" name="내용 개체 틀 2"/>
-          <p:cNvSpPr>
-            <a:spLocks noGrp="1"/>
-          </p:cNvSpPr>
-          <p:nvPr>
-            <p:ph idx="1"/>
-          </p:nvPr>
-        </p:nvSpPr>
-        <p:spPr>
-          <a:xfrm>
-            <a:off x="0" y="1032470"/>
-            <a:ext cx="12192000" cy="5825530"/>
-          </a:xfrm>
-        </p:spPr>
-        <p:txBody>
-          <a:bodyPr/>
-          <a:lstStyle/>
-          <a:p>
-            <a:r>
-              <a:rPr lang="en-US" altLang="ko-KR" dirty="0" smtClean="0"/>
-              <a:t>Controller Service Repository Pattern </a:t>
-            </a:r>
-            <a:r>
-              <a:rPr lang="ko-KR" altLang="en-US" dirty="0" smtClean="0"/>
-              <a:t>적용</a:t>
-            </a:r>
-            <a:endParaRPr lang="en-US" altLang="ko-KR" dirty="0" smtClean="0"/>
-          </a:p>
-          <a:p>
-            <a:r>
-              <a:rPr lang="en-US" altLang="ko-KR" dirty="0" err="1" smtClean="0"/>
-              <a:t>Postgre</a:t>
-            </a:r>
-            <a:r>
-              <a:rPr lang="en-US" altLang="ko-KR" dirty="0" smtClean="0"/>
-              <a:t> DB Connection</a:t>
-            </a:r>
-          </a:p>
-          <a:p>
-            <a:r>
-              <a:rPr lang="en-US" altLang="ko-KR" dirty="0" err="1" smtClean="0"/>
-              <a:t>Redis</a:t>
-            </a:r>
-            <a:r>
-              <a:rPr lang="en-US" altLang="ko-KR" dirty="0" smtClean="0"/>
-              <a:t> Connection / Subscribe</a:t>
-            </a:r>
-          </a:p>
-          <a:p>
-            <a:r>
-              <a:rPr lang="en-US" altLang="ko-KR" dirty="0" err="1" smtClean="0"/>
-              <a:t>Redis</a:t>
-            </a:r>
-            <a:r>
-              <a:rPr lang="en-US" altLang="ko-KR" dirty="0" smtClean="0"/>
-              <a:t> Sentinel -&gt; Master </a:t>
-            </a:r>
-            <a:r>
-              <a:rPr lang="ko-KR" altLang="en-US" dirty="0" smtClean="0"/>
-              <a:t>를 따라가도록 적용</a:t>
-            </a:r>
-            <a:r>
-              <a:rPr lang="en-US" altLang="ko-KR" dirty="0" smtClean="0"/>
-              <a:t>.</a:t>
-            </a:r>
-          </a:p>
-          <a:p>
-            <a:r>
-              <a:rPr lang="en-US" altLang="ko-KR" dirty="0" smtClean="0"/>
-              <a:t>Proxy Master </a:t>
-            </a:r>
-            <a:r>
-              <a:rPr lang="ko-KR" altLang="en-US" dirty="0" smtClean="0"/>
-              <a:t>상태 확인</a:t>
-            </a:r>
-            <a:r>
-              <a:rPr lang="en-US" altLang="ko-KR" dirty="0" smtClean="0"/>
-              <a:t>.</a:t>
-            </a:r>
-          </a:p>
-          <a:p>
-            <a:endParaRPr lang="en-US" altLang="ko-KR" dirty="0"/>
-          </a:p>
-        </p:txBody>
-      </p:sp>
-    </p:spTree>
-    <p:extLst>
-      <p:ext uri="{BB962C8B-B14F-4D97-AF65-F5344CB8AC3E}">
-        <p14:creationId xmlns:p14="http://schemas.microsoft.com/office/powerpoint/2010/main" val="3060246974"/>
-      </p:ext>
-    </p:extLst>
-  </p:cSld>
-  <p:clrMapOvr>
-    <a:masterClrMapping/>
-  </p:clrMapOvr>
-  <p:timing>
-    <p:tnLst>
-      <p:par>
-        <p:cTn id="1" dur="indefinite" restart="never" nodeType="tmRoot"/>
-      </p:par>
-    </p:tnLst>
-  </p:timing>
-</p:sld>
-</file>
-
-<file path=ppt/slides/slide6.xml><?xml version="1.0" encoding="utf-8"?>
-<p:sld xmlns:a="http://schemas.openxmlformats.org/drawingml/2006/main" xmlns:r="http://schemas.openxmlformats.org/officeDocument/2006/relationships" xmlns:p="http://schemas.openxmlformats.org/presentationml/2006/main">
-  <p:cSld>
-    <p:spTree>
-      <p:nvGrpSpPr>
-        <p:cNvPr id="1" name=""/>
-        <p:cNvGrpSpPr/>
-        <p:nvPr/>
-      </p:nvGrpSpPr>
-      <p:grpSpPr>
-        <a:xfrm>
-          <a:off x="0" y="0"/>
-          <a:ext cx="0" cy="0"/>
-          <a:chOff x="0" y="0"/>
-          <a:chExt cx="0" cy="0"/>
-        </a:xfrm>
-      </p:grpSpPr>
-      <p:sp>
-        <p:nvSpPr>
-          <p:cNvPr id="2" name="제목 1"/>
-          <p:cNvSpPr>
-            <a:spLocks noGrp="1"/>
-          </p:cNvSpPr>
-          <p:nvPr>
-            <p:ph type="title"/>
-          </p:nvPr>
-        </p:nvSpPr>
-        <p:spPr>
-          <a:xfrm>
-            <a:off x="0" y="18091"/>
-            <a:ext cx="12192000" cy="881301"/>
-          </a:xfrm>
-        </p:spPr>
-        <p:txBody>
-          <a:bodyPr>
-            <a:normAutofit fontScale="90000"/>
-          </a:bodyPr>
-          <a:lstStyle/>
-          <a:p>
-            <a:r>
-              <a:rPr lang="en-US" altLang="ko-KR" b="1" dirty="0" smtClean="0"/>
-              <a:t> </a:t>
-            </a:r>
-            <a:r>
-              <a:rPr lang="en-US" altLang="ko-KR" sz="4000" b="1" dirty="0" smtClean="0"/>
-              <a:t>Problem solution </a:t>
-            </a:r>
-            <a:r>
-              <a:rPr lang="en-US" altLang="ko-KR" b="1" dirty="0" smtClean="0"/>
-              <a:t>-</a:t>
-            </a:r>
-            <a:r>
-              <a:rPr lang="en-US" altLang="ko-KR" sz="3100" dirty="0"/>
-              <a:t>Controller Service Repository Pattern </a:t>
-            </a:r>
-            <a:r>
-              <a:rPr lang="ko-KR" altLang="en-US" sz="3100" dirty="0" smtClean="0"/>
-              <a:t>적용</a:t>
-            </a:r>
-            <a:endParaRPr lang="ko-KR" altLang="en-US" sz="3100" dirty="0"/>
-          </a:p>
-        </p:txBody>
-      </p:sp>
-      <p:sp>
-        <p:nvSpPr>
-          <p:cNvPr id="13" name="내용 개체 틀 2"/>
-          <p:cNvSpPr txBox="1">
-            <a:spLocks/>
-          </p:cNvSpPr>
-          <p:nvPr/>
-        </p:nvSpPr>
-        <p:spPr>
-          <a:xfrm>
-            <a:off x="0" y="1032470"/>
-            <a:ext cx="12192000" cy="5825530"/>
-          </a:xfrm>
-          <a:prstGeom prst="rect">
-            <a:avLst/>
-          </a:prstGeom>
-        </p:spPr>
-        <p:txBody>
-          <a:bodyPr vert="horz" lIns="91440" tIns="45720" rIns="91440" bIns="45720" rtlCol="0">
-            <a:normAutofit/>
-          </a:bodyPr>
-          <a:lstStyle>
-            <a:lvl1pPr marL="228600" indent="-228600" algn="l" defTabSz="914400" rtl="0" eaLnBrk="1" latinLnBrk="1" hangingPunct="1">
-              <a:lnSpc>
-                <a:spcPct val="90000"/>
-              </a:lnSpc>
-              <a:spcBef>
-                <a:spcPts val="1000"/>
-              </a:spcBef>
-              <a:buFont typeface="Arial" panose="020B0604020202020204" pitchFamily="34" charset="0"/>
-              <a:buChar char="•"/>
-              <a:defRPr sz="2800" kern="1200">
-                <a:solidFill>
-                  <a:schemeClr val="tx1"/>
-                </a:solidFill>
-                <a:latin typeface="+mn-lt"/>
-                <a:ea typeface="+mn-ea"/>
-                <a:cs typeface="+mn-cs"/>
-              </a:defRPr>
-            </a:lvl1pPr>
-            <a:lvl2pPr marL="685800" indent="-228600" algn="l" defTabSz="914400" rtl="0" eaLnBrk="1" latinLnBrk="1" hangingPunct="1">
-              <a:lnSpc>
-                <a:spcPct val="90000"/>
-              </a:lnSpc>
-              <a:spcBef>
-                <a:spcPts val="500"/>
-              </a:spcBef>
-              <a:buFont typeface="Arial" panose="020B0604020202020204" pitchFamily="34" charset="0"/>
-              <a:buChar char="•"/>
-              <a:defRPr sz="2400" kern="1200">
-                <a:solidFill>
-                  <a:schemeClr val="tx1"/>
-                </a:solidFill>
-                <a:latin typeface="+mn-lt"/>
-                <a:ea typeface="+mn-ea"/>
-                <a:cs typeface="+mn-cs"/>
-              </a:defRPr>
-            </a:lvl2pPr>
-            <a:lvl3pPr marL="1143000" indent="-228600" algn="l" defTabSz="914400" rtl="0" eaLnBrk="1" latinLnBrk="1" hangingPunct="1">
-              <a:lnSpc>
-                <a:spcPct val="90000"/>
-              </a:lnSpc>
-              <a:spcBef>
-                <a:spcPts val="500"/>
-              </a:spcBef>
-              <a:buFont typeface="Arial" panose="020B0604020202020204" pitchFamily="34" charset="0"/>
-              <a:buChar char="•"/>
-              <a:defRPr sz="2000" kern="1200">
-                <a:solidFill>
-                  <a:schemeClr val="tx1"/>
-                </a:solidFill>
-                <a:latin typeface="+mn-lt"/>
-                <a:ea typeface="+mn-ea"/>
-                <a:cs typeface="+mn-cs"/>
-              </a:defRPr>
-            </a:lvl3pPr>
-            <a:lvl4pPr marL="1600200" indent="-228600" algn="l" defTabSz="914400" rtl="0" eaLnBrk="1" latinLnBrk="1" hangingPunct="1">
-              <a:lnSpc>
-                <a:spcPct val="90000"/>
-              </a:lnSpc>
-              <a:spcBef>
-                <a:spcPts val="500"/>
-              </a:spcBef>
-              <a:buFont typeface="Arial" panose="020B0604020202020204" pitchFamily="34" charset="0"/>
-              <a:buChar char="•"/>
-              <a:defRPr sz="1800" kern="1200">
-                <a:solidFill>
-                  <a:schemeClr val="tx1"/>
-                </a:solidFill>
-                <a:latin typeface="+mn-lt"/>
-                <a:ea typeface="+mn-ea"/>
-                <a:cs typeface="+mn-cs"/>
-              </a:defRPr>
-            </a:lvl4pPr>
-            <a:lvl5pPr marL="2057400" indent="-228600" algn="l" defTabSz="914400" rtl="0" eaLnBrk="1" latinLnBrk="1" hangingPunct="1">
-              <a:lnSpc>
-                <a:spcPct val="90000"/>
-              </a:lnSpc>
-              <a:spcBef>
-                <a:spcPts val="500"/>
-              </a:spcBef>
-              <a:buFont typeface="Arial" panose="020B0604020202020204" pitchFamily="34" charset="0"/>
-              <a:buChar char="•"/>
-              <a:defRPr sz="1800" kern="1200">
-                <a:solidFill>
-                  <a:schemeClr val="tx1"/>
-                </a:solidFill>
-                <a:latin typeface="+mn-lt"/>
-                <a:ea typeface="+mn-ea"/>
-                <a:cs typeface="+mn-cs"/>
-              </a:defRPr>
-            </a:lvl5pPr>
-            <a:lvl6pPr marL="2514600" indent="-228600" algn="l" defTabSz="914400" rtl="0" eaLnBrk="1" latinLnBrk="1" hangingPunct="1">
-              <a:lnSpc>
-                <a:spcPct val="90000"/>
-              </a:lnSpc>
-              <a:spcBef>
-                <a:spcPts val="500"/>
-              </a:spcBef>
-              <a:buFont typeface="Arial" panose="020B0604020202020204" pitchFamily="34" charset="0"/>
-              <a:buChar char="•"/>
-              <a:defRPr sz="1800" kern="1200">
-                <a:solidFill>
-                  <a:schemeClr val="tx1"/>
-                </a:solidFill>
-                <a:latin typeface="+mn-lt"/>
-                <a:ea typeface="+mn-ea"/>
-                <a:cs typeface="+mn-cs"/>
-              </a:defRPr>
-            </a:lvl6pPr>
-            <a:lvl7pPr marL="2971800" indent="-228600" algn="l" defTabSz="914400" rtl="0" eaLnBrk="1" latinLnBrk="1" hangingPunct="1">
-              <a:lnSpc>
-                <a:spcPct val="90000"/>
-              </a:lnSpc>
-              <a:spcBef>
-                <a:spcPts val="500"/>
-              </a:spcBef>
-              <a:buFont typeface="Arial" panose="020B0604020202020204" pitchFamily="34" charset="0"/>
-              <a:buChar char="•"/>
-              <a:defRPr sz="1800" kern="1200">
-                <a:solidFill>
-                  <a:schemeClr val="tx1"/>
-                </a:solidFill>
-                <a:latin typeface="+mn-lt"/>
-                <a:ea typeface="+mn-ea"/>
-                <a:cs typeface="+mn-cs"/>
-              </a:defRPr>
-            </a:lvl7pPr>
-            <a:lvl8pPr marL="3429000" indent="-228600" algn="l" defTabSz="914400" rtl="0" eaLnBrk="1" latinLnBrk="1" hangingPunct="1">
-              <a:lnSpc>
-                <a:spcPct val="90000"/>
-              </a:lnSpc>
-              <a:spcBef>
-                <a:spcPts val="500"/>
-              </a:spcBef>
-              <a:buFont typeface="Arial" panose="020B0604020202020204" pitchFamily="34" charset="0"/>
-              <a:buChar char="•"/>
-              <a:defRPr sz="1800" kern="1200">
-                <a:solidFill>
-                  <a:schemeClr val="tx1"/>
-                </a:solidFill>
-                <a:latin typeface="+mn-lt"/>
-                <a:ea typeface="+mn-ea"/>
-                <a:cs typeface="+mn-cs"/>
-              </a:defRPr>
-            </a:lvl8pPr>
-            <a:lvl9pPr marL="3886200" indent="-228600" algn="l" defTabSz="914400" rtl="0" eaLnBrk="1" latinLnBrk="1" hangingPunct="1">
-              <a:lnSpc>
-                <a:spcPct val="90000"/>
-              </a:lnSpc>
-              <a:spcBef>
-                <a:spcPts val="500"/>
-              </a:spcBef>
-              <a:buFont typeface="Arial" panose="020B0604020202020204" pitchFamily="34" charset="0"/>
-              <a:buChar char="•"/>
-              <a:defRPr sz="1800" kern="1200">
-                <a:solidFill>
-                  <a:schemeClr val="tx1"/>
-                </a:solidFill>
-                <a:latin typeface="+mn-lt"/>
-                <a:ea typeface="+mn-ea"/>
-                <a:cs typeface="+mn-cs"/>
-              </a:defRPr>
-            </a:lvl9pPr>
-          </a:lstStyle>
-          <a:p>
-            <a:r>
-              <a:rPr lang="en-US" altLang="ko-KR" dirty="0" smtClean="0"/>
               <a:t>Controller/Action </a:t>
             </a:r>
             <a:r>
@@ -5311,7 +5213,6 @@
               <a:rPr lang="en-US" altLang="ko-KR" dirty="0" smtClean="0"/>
               <a:t>.</a:t>
             </a:r>
-            <a:endParaRPr lang="en-US" altLang="ko-KR" dirty="0" smtClean="0"/>
           </a:p>
         </p:txBody>
       </p:sp>
@@ -5510,7 +5411,7 @@
 </p:sld>
 </file>
 
-<file path=ppt/slides/slide7.xml><?xml version="1.0" encoding="utf-8"?>
+<file path=ppt/slides/slide6.xml><?xml version="1.0" encoding="utf-8"?>
 <p:sld xmlns:a="http://schemas.openxmlformats.org/drawingml/2006/main" xmlns:r="http://schemas.openxmlformats.org/officeDocument/2006/relationships" xmlns:p="http://schemas.openxmlformats.org/presentationml/2006/main">
   <p:cSld>
     <p:spTree>
@@ -6138,7 +6039,7 @@
 </p:sld>
 </file>
 
-<file path=ppt/slides/slide8.xml><?xml version="1.0" encoding="utf-8"?>
+<file path=ppt/slides/slide7.xml><?xml version="1.0" encoding="utf-8"?>
 <p:sld xmlns:a="http://schemas.openxmlformats.org/drawingml/2006/main" xmlns:r="http://schemas.openxmlformats.org/officeDocument/2006/relationships" xmlns:p="http://schemas.openxmlformats.org/presentationml/2006/main">
   <p:cSld>
     <p:spTree>
@@ -6407,7 +6308,6 @@
               <a:rPr lang="en-US" altLang="ko-KR" dirty="0" smtClean="0"/>
               <a:t>.</a:t>
             </a:r>
-            <a:endParaRPr lang="en-US" altLang="ko-KR" dirty="0" smtClean="0"/>
           </a:p>
         </p:txBody>
       </p:sp>
@@ -6503,7 +6403,7 @@
 </p:sld>
 </file>
 
-<file path=ppt/slides/slide9.xml><?xml version="1.0" encoding="utf-8"?>
+<file path=ppt/slides/slide8.xml><?xml version="1.0" encoding="utf-8"?>
 <p:sld xmlns:a="http://schemas.openxmlformats.org/drawingml/2006/main" xmlns:r="http://schemas.openxmlformats.org/officeDocument/2006/relationships" xmlns:p="http://schemas.openxmlformats.org/presentationml/2006/main">
   <p:cSld>
     <p:spTree>
@@ -6901,6 +6801,478 @@
     <p:extLst>
       <p:ext uri="{BB962C8B-B14F-4D97-AF65-F5344CB8AC3E}">
         <p14:creationId xmlns:p14="http://schemas.microsoft.com/office/powerpoint/2010/main" val="557716666"/>
+      </p:ext>
+    </p:extLst>
+  </p:cSld>
+  <p:clrMapOvr>
+    <a:masterClrMapping/>
+  </p:clrMapOvr>
+  <p:timing>
+    <p:tnLst>
+      <p:par>
+        <p:cTn id="1" dur="indefinite" restart="never" nodeType="tmRoot"/>
+      </p:par>
+    </p:tnLst>
+  </p:timing>
+</p:sld>
+</file>
+
+<file path=ppt/slides/slide9.xml><?xml version="1.0" encoding="utf-8"?>
+<p:sld xmlns:a="http://schemas.openxmlformats.org/drawingml/2006/main" xmlns:r="http://schemas.openxmlformats.org/officeDocument/2006/relationships" xmlns:p="http://schemas.openxmlformats.org/presentationml/2006/main">
+  <p:cSld>
+    <p:spTree>
+      <p:nvGrpSpPr>
+        <p:cNvPr id="1" name=""/>
+        <p:cNvGrpSpPr/>
+        <p:nvPr/>
+      </p:nvGrpSpPr>
+      <p:grpSpPr>
+        <a:xfrm>
+          <a:off x="0" y="0"/>
+          <a:ext cx="0" cy="0"/>
+          <a:chOff x="0" y="0"/>
+          <a:chExt cx="0" cy="0"/>
+        </a:xfrm>
+      </p:grpSpPr>
+      <p:sp>
+        <p:nvSpPr>
+          <p:cNvPr id="2" name="제목 1"/>
+          <p:cNvSpPr>
+            <a:spLocks noGrp="1"/>
+          </p:cNvSpPr>
+          <p:nvPr>
+            <p:ph type="title"/>
+          </p:nvPr>
+        </p:nvSpPr>
+        <p:spPr>
+          <a:xfrm>
+            <a:off x="0" y="18091"/>
+            <a:ext cx="12192000" cy="881301"/>
+          </a:xfrm>
+        </p:spPr>
+        <p:txBody>
+          <a:bodyPr>
+            <a:normAutofit/>
+          </a:bodyPr>
+          <a:lstStyle/>
+          <a:p>
+            <a:r>
+              <a:rPr lang="en-US" altLang="ko-KR" b="1" dirty="0" smtClean="0"/>
+              <a:t> </a:t>
+            </a:r>
+            <a:r>
+              <a:rPr lang="en-US" altLang="ko-KR" sz="4000" b="1" dirty="0" smtClean="0"/>
+              <a:t>Problem solution </a:t>
+            </a:r>
+            <a:r>
+              <a:rPr lang="en-US" altLang="ko-KR" b="1" dirty="0" smtClean="0"/>
+              <a:t>- </a:t>
+            </a:r>
+            <a:r>
+              <a:rPr lang="en-US" altLang="ko-KR" sz="3200" dirty="0"/>
+              <a:t>Proxy Master </a:t>
+            </a:r>
+            <a:r>
+              <a:rPr lang="ko-KR" altLang="en-US" sz="3200" dirty="0"/>
+              <a:t>상태 확인</a:t>
+            </a:r>
+            <a:r>
+              <a:rPr lang="en-US" altLang="ko-KR" sz="3200" dirty="0" smtClean="0"/>
+              <a:t>.</a:t>
+            </a:r>
+            <a:endParaRPr lang="ko-KR" altLang="en-US" sz="3100" dirty="0"/>
+          </a:p>
+        </p:txBody>
+      </p:sp>
+      <p:sp>
+        <p:nvSpPr>
+          <p:cNvPr id="13" name="내용 개체 틀 2"/>
+          <p:cNvSpPr txBox="1">
+            <a:spLocks/>
+          </p:cNvSpPr>
+          <p:nvPr/>
+        </p:nvSpPr>
+        <p:spPr>
+          <a:xfrm>
+            <a:off x="0" y="803868"/>
+            <a:ext cx="12192000" cy="6054132"/>
+          </a:xfrm>
+          <a:prstGeom prst="rect">
+            <a:avLst/>
+          </a:prstGeom>
+        </p:spPr>
+        <p:txBody>
+          <a:bodyPr vert="horz" lIns="91440" tIns="45720" rIns="91440" bIns="45720" rtlCol="0">
+            <a:normAutofit/>
+          </a:bodyPr>
+          <a:lstStyle>
+            <a:lvl1pPr marL="228600" indent="-228600" algn="l" defTabSz="914400" rtl="0" eaLnBrk="1" latinLnBrk="1" hangingPunct="1">
+              <a:lnSpc>
+                <a:spcPct val="90000"/>
+              </a:lnSpc>
+              <a:spcBef>
+                <a:spcPts val="1000"/>
+              </a:spcBef>
+              <a:buFont typeface="Arial" panose="020B0604020202020204" pitchFamily="34" charset="0"/>
+              <a:buChar char="•"/>
+              <a:defRPr sz="2800" kern="1200">
+                <a:solidFill>
+                  <a:schemeClr val="tx1"/>
+                </a:solidFill>
+                <a:latin typeface="+mn-lt"/>
+                <a:ea typeface="+mn-ea"/>
+                <a:cs typeface="+mn-cs"/>
+              </a:defRPr>
+            </a:lvl1pPr>
+            <a:lvl2pPr marL="685800" indent="-228600" algn="l" defTabSz="914400" rtl="0" eaLnBrk="1" latinLnBrk="1" hangingPunct="1">
+              <a:lnSpc>
+                <a:spcPct val="90000"/>
+              </a:lnSpc>
+              <a:spcBef>
+                <a:spcPts val="500"/>
+              </a:spcBef>
+              <a:buFont typeface="Arial" panose="020B0604020202020204" pitchFamily="34" charset="0"/>
+              <a:buChar char="•"/>
+              <a:defRPr sz="2400" kern="1200">
+                <a:solidFill>
+                  <a:schemeClr val="tx1"/>
+                </a:solidFill>
+                <a:latin typeface="+mn-lt"/>
+                <a:ea typeface="+mn-ea"/>
+                <a:cs typeface="+mn-cs"/>
+              </a:defRPr>
+            </a:lvl2pPr>
+            <a:lvl3pPr marL="1143000" indent="-228600" algn="l" defTabSz="914400" rtl="0" eaLnBrk="1" latinLnBrk="1" hangingPunct="1">
+              <a:lnSpc>
+                <a:spcPct val="90000"/>
+              </a:lnSpc>
+              <a:spcBef>
+                <a:spcPts val="500"/>
+              </a:spcBef>
+              <a:buFont typeface="Arial" panose="020B0604020202020204" pitchFamily="34" charset="0"/>
+              <a:buChar char="•"/>
+              <a:defRPr sz="2000" kern="1200">
+                <a:solidFill>
+                  <a:schemeClr val="tx1"/>
+                </a:solidFill>
+                <a:latin typeface="+mn-lt"/>
+                <a:ea typeface="+mn-ea"/>
+                <a:cs typeface="+mn-cs"/>
+              </a:defRPr>
+            </a:lvl3pPr>
+            <a:lvl4pPr marL="1600200" indent="-228600" algn="l" defTabSz="914400" rtl="0" eaLnBrk="1" latinLnBrk="1" hangingPunct="1">
+              <a:lnSpc>
+                <a:spcPct val="90000"/>
+              </a:lnSpc>
+              <a:spcBef>
+                <a:spcPts val="500"/>
+              </a:spcBef>
+              <a:buFont typeface="Arial" panose="020B0604020202020204" pitchFamily="34" charset="0"/>
+              <a:buChar char="•"/>
+              <a:defRPr sz="1800" kern="1200">
+                <a:solidFill>
+                  <a:schemeClr val="tx1"/>
+                </a:solidFill>
+                <a:latin typeface="+mn-lt"/>
+                <a:ea typeface="+mn-ea"/>
+                <a:cs typeface="+mn-cs"/>
+              </a:defRPr>
+            </a:lvl4pPr>
+            <a:lvl5pPr marL="2057400" indent="-228600" algn="l" defTabSz="914400" rtl="0" eaLnBrk="1" latinLnBrk="1" hangingPunct="1">
+              <a:lnSpc>
+                <a:spcPct val="90000"/>
+              </a:lnSpc>
+              <a:spcBef>
+                <a:spcPts val="500"/>
+              </a:spcBef>
+              <a:buFont typeface="Arial" panose="020B0604020202020204" pitchFamily="34" charset="0"/>
+              <a:buChar char="•"/>
+              <a:defRPr sz="1800" kern="1200">
+                <a:solidFill>
+                  <a:schemeClr val="tx1"/>
+                </a:solidFill>
+                <a:latin typeface="+mn-lt"/>
+                <a:ea typeface="+mn-ea"/>
+                <a:cs typeface="+mn-cs"/>
+              </a:defRPr>
+            </a:lvl5pPr>
+            <a:lvl6pPr marL="2514600" indent="-228600" algn="l" defTabSz="914400" rtl="0" eaLnBrk="1" latinLnBrk="1" hangingPunct="1">
+              <a:lnSpc>
+                <a:spcPct val="90000"/>
+              </a:lnSpc>
+              <a:spcBef>
+                <a:spcPts val="500"/>
+              </a:spcBef>
+              <a:buFont typeface="Arial" panose="020B0604020202020204" pitchFamily="34" charset="0"/>
+              <a:buChar char="•"/>
+              <a:defRPr sz="1800" kern="1200">
+                <a:solidFill>
+                  <a:schemeClr val="tx1"/>
+                </a:solidFill>
+                <a:latin typeface="+mn-lt"/>
+                <a:ea typeface="+mn-ea"/>
+                <a:cs typeface="+mn-cs"/>
+              </a:defRPr>
+            </a:lvl6pPr>
+            <a:lvl7pPr marL="2971800" indent="-228600" algn="l" defTabSz="914400" rtl="0" eaLnBrk="1" latinLnBrk="1" hangingPunct="1">
+              <a:lnSpc>
+                <a:spcPct val="90000"/>
+              </a:lnSpc>
+              <a:spcBef>
+                <a:spcPts val="500"/>
+              </a:spcBef>
+              <a:buFont typeface="Arial" panose="020B0604020202020204" pitchFamily="34" charset="0"/>
+              <a:buChar char="•"/>
+              <a:defRPr sz="1800" kern="1200">
+                <a:solidFill>
+                  <a:schemeClr val="tx1"/>
+                </a:solidFill>
+                <a:latin typeface="+mn-lt"/>
+                <a:ea typeface="+mn-ea"/>
+                <a:cs typeface="+mn-cs"/>
+              </a:defRPr>
+            </a:lvl7pPr>
+            <a:lvl8pPr marL="3429000" indent="-228600" algn="l" defTabSz="914400" rtl="0" eaLnBrk="1" latinLnBrk="1" hangingPunct="1">
+              <a:lnSpc>
+                <a:spcPct val="90000"/>
+              </a:lnSpc>
+              <a:spcBef>
+                <a:spcPts val="500"/>
+              </a:spcBef>
+              <a:buFont typeface="Arial" panose="020B0604020202020204" pitchFamily="34" charset="0"/>
+              <a:buChar char="•"/>
+              <a:defRPr sz="1800" kern="1200">
+                <a:solidFill>
+                  <a:schemeClr val="tx1"/>
+                </a:solidFill>
+                <a:latin typeface="+mn-lt"/>
+                <a:ea typeface="+mn-ea"/>
+                <a:cs typeface="+mn-cs"/>
+              </a:defRPr>
+            </a:lvl8pPr>
+            <a:lvl9pPr marL="3886200" indent="-228600" algn="l" defTabSz="914400" rtl="0" eaLnBrk="1" latinLnBrk="1" hangingPunct="1">
+              <a:lnSpc>
+                <a:spcPct val="90000"/>
+              </a:lnSpc>
+              <a:spcBef>
+                <a:spcPts val="500"/>
+              </a:spcBef>
+              <a:buFont typeface="Arial" panose="020B0604020202020204" pitchFamily="34" charset="0"/>
+              <a:buChar char="•"/>
+              <a:defRPr sz="1800" kern="1200">
+                <a:solidFill>
+                  <a:schemeClr val="tx1"/>
+                </a:solidFill>
+                <a:latin typeface="+mn-lt"/>
+                <a:ea typeface="+mn-ea"/>
+                <a:cs typeface="+mn-cs"/>
+              </a:defRPr>
+            </a:lvl9pPr>
+          </a:lstStyle>
+          <a:p>
+            <a:r>
+              <a:rPr lang="en-US" altLang="ko-KR" dirty="0" smtClean="0"/>
+              <a:t>Proxy Socket </a:t>
+            </a:r>
+            <a:r>
+              <a:rPr lang="ko-KR" altLang="en-US" dirty="0" smtClean="0"/>
+              <a:t>연결 후 </a:t>
+            </a:r>
+            <a:r>
+              <a:rPr lang="en-US" altLang="ko-KR" dirty="0" smtClean="0"/>
+              <a:t>Command </a:t>
+            </a:r>
+            <a:r>
+              <a:rPr lang="ko-KR" altLang="en-US" dirty="0" smtClean="0"/>
+              <a:t>로 데이터 가져오도록 함</a:t>
+            </a:r>
+            <a:r>
+              <a:rPr lang="en-US" altLang="ko-KR" dirty="0" smtClean="0"/>
+              <a:t>.</a:t>
+            </a:r>
+          </a:p>
+          <a:p>
+            <a:r>
+              <a:rPr lang="ko-KR" altLang="en-US" dirty="0" smtClean="0"/>
+              <a:t>해당 </a:t>
+            </a:r>
+            <a:r>
+              <a:rPr lang="en-US" altLang="ko-KR" dirty="0" smtClean="0"/>
+              <a:t>MAS </a:t>
+            </a:r>
+            <a:r>
+              <a:rPr lang="ko-KR" altLang="en-US" dirty="0" smtClean="0"/>
+              <a:t>의 </a:t>
+            </a:r>
+            <a:r>
+              <a:rPr lang="en-US" altLang="ko-KR" dirty="0" smtClean="0"/>
+              <a:t>IP </a:t>
+            </a:r>
+            <a:r>
+              <a:rPr lang="ko-KR" altLang="en-US" dirty="0" smtClean="0"/>
+              <a:t>주소가 </a:t>
+            </a:r>
+            <a:r>
+              <a:rPr lang="en-US" altLang="ko-KR" dirty="0" smtClean="0"/>
+              <a:t>Proxy Master </a:t>
+            </a:r>
+            <a:r>
+              <a:rPr lang="ko-KR" altLang="en-US" dirty="0" smtClean="0"/>
+              <a:t>주소 를 가지고 있는지 확인</a:t>
+            </a:r>
+            <a:r>
+              <a:rPr lang="en-US" altLang="ko-KR" dirty="0" smtClean="0"/>
+              <a:t>.</a:t>
+            </a:r>
+          </a:p>
+          <a:p>
+            <a:endParaRPr lang="en-US" altLang="ko-KR" dirty="0"/>
+          </a:p>
+          <a:p>
+            <a:endParaRPr lang="en-US" altLang="ko-KR" dirty="0" smtClean="0"/>
+          </a:p>
+          <a:p>
+            <a:endParaRPr lang="en-US" altLang="ko-KR" dirty="0"/>
+          </a:p>
+          <a:p>
+            <a:endParaRPr lang="en-US" altLang="ko-KR" dirty="0" smtClean="0"/>
+          </a:p>
+          <a:p>
+            <a:endParaRPr lang="en-US" altLang="ko-KR" dirty="0"/>
+          </a:p>
+          <a:p>
+            <a:r>
+              <a:rPr lang="en-US" altLang="ko-KR" dirty="0" smtClean="0"/>
+              <a:t>                                     Proxy </a:t>
+            </a:r>
+            <a:r>
+              <a:rPr lang="en-US" altLang="ko-KR" dirty="0" err="1" smtClean="0"/>
+              <a:t>Url</a:t>
+            </a:r>
+            <a:r>
+              <a:rPr lang="en-US" altLang="ko-KR" dirty="0" smtClean="0"/>
+              <a:t> </a:t>
+            </a:r>
+            <a:r>
+              <a:rPr lang="ko-KR" altLang="en-US" dirty="0" smtClean="0"/>
+              <a:t>로 </a:t>
+            </a:r>
+            <a:r>
+              <a:rPr lang="en-US" altLang="ko-KR" dirty="0" smtClean="0"/>
+              <a:t>http </a:t>
+            </a:r>
+            <a:r>
+              <a:rPr lang="ko-KR" altLang="en-US" dirty="0" smtClean="0"/>
+              <a:t>통신으로 데이터 받아 옴</a:t>
+            </a:r>
+            <a:r>
+              <a:rPr lang="en-US" altLang="ko-KR" dirty="0"/>
+              <a:t>.</a:t>
+            </a:r>
+            <a:endParaRPr lang="en-US" altLang="ko-KR" dirty="0" smtClean="0"/>
+          </a:p>
+        </p:txBody>
+      </p:sp>
+      <p:pic>
+        <p:nvPicPr>
+          <p:cNvPr id="3" name="그림 2"/>
+          <p:cNvPicPr>
+            <a:picLocks noChangeAspect="1"/>
+          </p:cNvPicPr>
+          <p:nvPr/>
+        </p:nvPicPr>
+        <p:blipFill>
+          <a:blip r:embed="rId2"/>
+          <a:stretch>
+            <a:fillRect/>
+          </a:stretch>
+        </p:blipFill>
+        <p:spPr>
+          <a:xfrm>
+            <a:off x="70058" y="2147080"/>
+            <a:ext cx="6839905" cy="1638529"/>
+          </a:xfrm>
+          <a:prstGeom prst="rect">
+            <a:avLst/>
+          </a:prstGeom>
+        </p:spPr>
+      </p:pic>
+      <p:pic>
+        <p:nvPicPr>
+          <p:cNvPr id="6" name="그림 5"/>
+          <p:cNvPicPr>
+            <a:picLocks noChangeAspect="1"/>
+          </p:cNvPicPr>
+          <p:nvPr/>
+        </p:nvPicPr>
+        <p:blipFill>
+          <a:blip r:embed="rId3"/>
+          <a:stretch>
+            <a:fillRect/>
+          </a:stretch>
+        </p:blipFill>
+        <p:spPr>
+          <a:xfrm>
+            <a:off x="0" y="3830934"/>
+            <a:ext cx="4563112" cy="2981741"/>
+          </a:xfrm>
+          <a:prstGeom prst="rect">
+            <a:avLst/>
+          </a:prstGeom>
+        </p:spPr>
+      </p:pic>
+      <p:pic>
+        <p:nvPicPr>
+          <p:cNvPr id="8" name="그림 7"/>
+          <p:cNvPicPr>
+            <a:picLocks noChangeAspect="1"/>
+          </p:cNvPicPr>
+          <p:nvPr/>
+        </p:nvPicPr>
+        <p:blipFill>
+          <a:blip r:embed="rId4"/>
+          <a:stretch>
+            <a:fillRect/>
+          </a:stretch>
+        </p:blipFill>
+        <p:spPr>
+          <a:xfrm>
+            <a:off x="4910348" y="4831198"/>
+            <a:ext cx="6325483" cy="1981477"/>
+          </a:xfrm>
+          <a:prstGeom prst="rect">
+            <a:avLst/>
+          </a:prstGeom>
+        </p:spPr>
+      </p:pic>
+      <p:pic>
+        <p:nvPicPr>
+          <p:cNvPr id="4" name="그림 3"/>
+          <p:cNvPicPr>
+            <a:picLocks noChangeAspect="1"/>
+          </p:cNvPicPr>
+          <p:nvPr/>
+        </p:nvPicPr>
+        <p:blipFill>
+          <a:blip r:embed="rId5"/>
+          <a:stretch>
+            <a:fillRect/>
+          </a:stretch>
+        </p:blipFill>
+        <p:spPr>
+          <a:xfrm>
+            <a:off x="70058" y="1749281"/>
+            <a:ext cx="7116168" cy="352474"/>
+          </a:xfrm>
+          <a:prstGeom prst="rect">
+            <a:avLst/>
+          </a:prstGeom>
+        </p:spPr>
+      </p:pic>
+    </p:spTree>
+    <p:extLst>
+      <p:ext uri="{BB962C8B-B14F-4D97-AF65-F5344CB8AC3E}">
+        <p14:creationId xmlns:p14="http://schemas.microsoft.com/office/powerpoint/2010/main" val="1426452746"/>
       </p:ext>
     </p:extLst>
   </p:cSld>

</xml_diff>